<commit_message>
docs: exec deck v2.1 — microservices architecture slides
</commit_message>
<xml_diff>
--- a/docs/decks/LedgeRX-Executive-Briefing-v2.pptx
+++ b/docs/decks/LedgeRX-Executive-Briefing-v2.pptx
@@ -17,9 +17,11 @@
     <p:sldId id="265" r:id="rId11"/>
     <p:sldId id="266" r:id="rId12"/>
     <p:sldId id="267" r:id="rId13"/>
+    <p:sldId id="268" r:id="rId14"/>
+    <p:sldId id="269" r:id="rId15"/>
   </p:sldIdLst>
   <p:notesMasterIdLst>
-    <p:notesMasterId r:id="rId14"/>
+    <p:notesMasterId r:id="rId16"/>
   </p:notesMasterIdLst>
   <p:sldSz cx="12192000" cy="6858000"/>
   <p:notesSz cx="6858000" cy="12192000"/>
@@ -801,6 +803,182 @@
             <a:fld id="{F7021451-1387-4CA6-816F-3879F97B5CBC}" type="slidenum">
               <a:rPr lang="en-US"/>
               <a:t>12</a:t>
+            </a:fld>
+            <a:endParaRPr lang="en-US"/>
+          </a:p>
+        </p:txBody>
+      </p:sp>
+    </p:spTree>
+    <p:extLst>
+      <p:ext uri="{BB962C8B-B14F-4D97-AF65-F5344CB8AC3E}">
+        <p14:creationId xmlns:p14="http://schemas.microsoft.com/office/powerpoint/2010/main" val="1024086991"/>
+      </p:ext>
+    </p:extLst>
+  </p:cSld>
+  <p:clrMapOvr>
+    <a:masterClrMapping/>
+  </p:clrMapOvr>
+</p:notes>
+</file>
+
+<file path=ppt/notesSlides/notesSlide13.xml><?xml version="1.0" encoding="utf-8"?>
+<p:notes xmlns:a="http://schemas.openxmlformats.org/drawingml/2006/main" xmlns:r="http://schemas.openxmlformats.org/officeDocument/2006/relationships" xmlns:p="http://schemas.openxmlformats.org/presentationml/2006/main">
+  <p:cSld>
+    <p:spTree>
+      <p:nvGrpSpPr>
+        <p:cNvPr id="1" name=""/>
+        <p:cNvGrpSpPr/>
+        <p:nvPr/>
+      </p:nvGrpSpPr>
+      <p:grpSpPr>
+        <a:xfrm>
+          <a:off x="0" y="0"/>
+          <a:ext cx="0" cy="0"/>
+          <a:chOff x="0" y="0"/>
+          <a:chExt cx="0" cy="0"/>
+        </a:xfrm>
+      </p:grpSpPr>
+      <p:sp>
+        <p:nvSpPr>
+          <p:cNvPr id="2" name="Slide Image Placeholder 1"/>
+          <p:cNvSpPr>
+            <a:spLocks noGrp="1" noRot="1" noChangeAspect="1"/>
+          </p:cNvSpPr>
+          <p:nvPr>
+            <p:ph type="sldImg"/>
+          </p:nvPr>
+        </p:nvSpPr>
+        <p:spPr/>
+      </p:sp>
+      <p:sp>
+        <p:nvSpPr>
+          <p:cNvPr id="3" name="Notes Placeholder 2"/>
+          <p:cNvSpPr>
+            <a:spLocks noGrp="1"/>
+          </p:cNvSpPr>
+          <p:nvPr>
+            <p:ph type="body" idx="1"/>
+          </p:nvPr>
+        </p:nvSpPr>
+        <p:spPr/>
+        <p:txBody>
+          <a:bodyPr/>
+          <a:lstStyle/>
+          <a:p>
+            <a:r>
+              <a:rPr lang="en-US" dirty="0"/>
+              <a:t/>
+            </a:r>
+            <a:endParaRPr lang="en-US" dirty="0"/>
+          </a:p>
+        </p:txBody>
+      </p:sp>
+      <p:sp>
+        <p:nvSpPr>
+          <p:cNvPr id="4" name="Slide Number Placeholder 3"/>
+          <p:cNvSpPr>
+            <a:spLocks noGrp="1"/>
+          </p:cNvSpPr>
+          <p:nvPr>
+            <p:ph type="sldNum" sz="quarter" idx="10"/>
+          </p:nvPr>
+        </p:nvSpPr>
+        <p:spPr/>
+        <p:txBody>
+          <a:bodyPr/>
+          <a:lstStyle/>
+          <a:p>
+            <a:fld id="{F7021451-1387-4CA6-816F-3879F97B5CBC}" type="slidenum">
+              <a:rPr lang="en-US"/>
+              <a:t>13</a:t>
+            </a:fld>
+            <a:endParaRPr lang="en-US"/>
+          </a:p>
+        </p:txBody>
+      </p:sp>
+    </p:spTree>
+    <p:extLst>
+      <p:ext uri="{BB962C8B-B14F-4D97-AF65-F5344CB8AC3E}">
+        <p14:creationId xmlns:p14="http://schemas.microsoft.com/office/powerpoint/2010/main" val="1024086991"/>
+      </p:ext>
+    </p:extLst>
+  </p:cSld>
+  <p:clrMapOvr>
+    <a:masterClrMapping/>
+  </p:clrMapOvr>
+</p:notes>
+</file>
+
+<file path=ppt/notesSlides/notesSlide14.xml><?xml version="1.0" encoding="utf-8"?>
+<p:notes xmlns:a="http://schemas.openxmlformats.org/drawingml/2006/main" xmlns:r="http://schemas.openxmlformats.org/officeDocument/2006/relationships" xmlns:p="http://schemas.openxmlformats.org/presentationml/2006/main">
+  <p:cSld>
+    <p:spTree>
+      <p:nvGrpSpPr>
+        <p:cNvPr id="1" name=""/>
+        <p:cNvGrpSpPr/>
+        <p:nvPr/>
+      </p:nvGrpSpPr>
+      <p:grpSpPr>
+        <a:xfrm>
+          <a:off x="0" y="0"/>
+          <a:ext cx="0" cy="0"/>
+          <a:chOff x="0" y="0"/>
+          <a:chExt cx="0" cy="0"/>
+        </a:xfrm>
+      </p:grpSpPr>
+      <p:sp>
+        <p:nvSpPr>
+          <p:cNvPr id="2" name="Slide Image Placeholder 1"/>
+          <p:cNvSpPr>
+            <a:spLocks noGrp="1" noRot="1" noChangeAspect="1"/>
+          </p:cNvSpPr>
+          <p:nvPr>
+            <p:ph type="sldImg"/>
+          </p:nvPr>
+        </p:nvSpPr>
+        <p:spPr/>
+      </p:sp>
+      <p:sp>
+        <p:nvSpPr>
+          <p:cNvPr id="3" name="Notes Placeholder 2"/>
+          <p:cNvSpPr>
+            <a:spLocks noGrp="1"/>
+          </p:cNvSpPr>
+          <p:nvPr>
+            <p:ph type="body" idx="1"/>
+          </p:nvPr>
+        </p:nvSpPr>
+        <p:spPr/>
+        <p:txBody>
+          <a:bodyPr/>
+          <a:lstStyle/>
+          <a:p>
+            <a:r>
+              <a:rPr lang="en-US" dirty="0"/>
+              <a:t/>
+            </a:r>
+            <a:endParaRPr lang="en-US" dirty="0"/>
+          </a:p>
+        </p:txBody>
+      </p:sp>
+      <p:sp>
+        <p:nvSpPr>
+          <p:cNvPr id="4" name="Slide Number Placeholder 3"/>
+          <p:cNvSpPr>
+            <a:spLocks noGrp="1"/>
+          </p:cNvSpPr>
+          <p:nvPr>
+            <p:ph type="sldNum" sz="quarter" idx="10"/>
+          </p:nvPr>
+        </p:nvSpPr>
+        <p:spPr/>
+        <p:txBody>
+          <a:bodyPr/>
+          <a:lstStyle/>
+          <a:p>
+            <a:fld id="{F7021451-1387-4CA6-816F-3879F97B5CBC}" type="slidenum">
+              <a:rPr lang="en-US"/>
+              <a:t>14</a:t>
             </a:fld>
             <a:endParaRPr lang="en-US"/>
           </a:p>
@@ -2054,7 +2232,7 @@
                 <a:ea typeface="Calibri" pitchFamily="34" charset="-122"/>
                 <a:cs typeface="Calibri" pitchFamily="34" charset="-120"/>
               </a:rPr>
-              <a:t>Confidential  ·  First draft for internal review</a:t>
+              <a:t>Confidential  ·  Executive draft v2.1</a:t>
             </a:r>
             <a:endParaRPr lang="en-US" sz="1200" dirty="0"/>
           </a:p>
@@ -2171,7 +2349,7 @@
                 <a:ea typeface="Calibri" pitchFamily="34" charset="-122"/>
                 <a:cs typeface="Calibri" pitchFamily="34" charset="-120"/>
               </a:rPr>
-              <a:t>Deploy</a:t>
+              <a:t>Shape</a:t>
             </a:r>
             <a:endParaRPr lang="en-US" sz="1100" dirty="0"/>
           </a:p>
@@ -2210,7 +2388,7 @@
                 <a:ea typeface="Calibri" pitchFamily="34" charset="-122"/>
                 <a:cs typeface="Calibri" pitchFamily="34" charset="-120"/>
               </a:rPr>
-              <a:t>Client cluster</a:t>
+              <a:t>Domain microservice</a:t>
             </a:r>
             <a:endParaRPr lang="en-US" sz="1800" dirty="0"/>
           </a:p>
@@ -2450,7 +2628,7 @@
                 <a:ea typeface="Calibri" pitchFamily="34" charset="-122"/>
                 <a:cs typeface="Calibri" pitchFamily="34" charset="-120"/>
               </a:rPr>
-              <a:t>System architecture</a:t>
+              <a:t>Architecture — processing spine</a:t>
             </a:r>
             <a:endParaRPr lang="en-US" sz="2800" dirty="0"/>
           </a:p>
@@ -2489,7 +2667,7 @@
                 <a:ea typeface="Calibri" pitchFamily="34" charset="-122"/>
                 <a:cs typeface="Calibri" pitchFamily="34" charset="-120"/>
               </a:rPr>
-              <a:t>In-cluster engine with a clear processing spine</a:t>
+              <a:t>Inside the LedgeRX domain service</a:t>
             </a:r>
             <a:endParaRPr lang="en-US" sz="1400" dirty="0"/>
           </a:p>
@@ -3128,7 +3306,7 @@
                 <a:ea typeface="Calibri" pitchFamily="34" charset="-122"/>
                 <a:cs typeface="Calibri" pitchFamily="34" charset="-120"/>
               </a:rPr>
-              <a:t>Java 17 · Spring Boot  ·  Product HTTP APIs only for new work</a:t>
+              <a:t>Java 17 · Spring Boot  ·  Product HTTP APIs for new work</a:t>
             </a:r>
             <a:endParaRPr lang="en-US" sz="1400" dirty="0"/>
           </a:p>
@@ -3602,7 +3780,7 @@
                 <a:ea typeface="Calibri" pitchFamily="34" charset="-122"/>
                 <a:cs typeface="Calibri" pitchFamily="34" charset="-120"/>
               </a:rPr>
-              <a:t>Business outcomes</a:t>
+              <a:t>Microservices architecture</a:t>
             </a:r>
             <a:endParaRPr lang="en-US" sz="2800" dirty="0"/>
           </a:p>
@@ -3641,7 +3819,7 @@
                 <a:ea typeface="Calibri" pitchFamily="34" charset="-122"/>
                 <a:cs typeface="Calibri" pitchFamily="34" charset="-120"/>
               </a:rPr>
-              <a:t>What leadership should expect</a:t>
+              <a:t>LedgeRX as a bounded domain service in the client platform</a:t>
             </a:r>
             <a:endParaRPr lang="en-US" sz="1400" dirty="0"/>
           </a:p>
@@ -3655,12 +3833,73 @@
         </p:nvSpPr>
         <p:spPr>
           <a:xfrm>
-            <a:off x="502920" y="1325880"/>
-            <a:ext cx="3611880" cy="2103120"/>
+            <a:off x="502920" y="1188720"/>
+            <a:ext cx="11155680" cy="640080"/>
           </a:xfrm>
           <a:prstGeom prst="roundRect">
             <a:avLst>
-              <a:gd name="adj" fmla="val 2609"/>
+              <a:gd name="adj" fmla="val 8571"/>
+            </a:avLst>
+          </a:prstGeom>
+          <a:solidFill>
+            <a:srgbClr val="E6F5F3"/>
+          </a:solidFill>
+          <a:ln/>
+        </p:spPr>
+      </p:sp>
+      <p:sp>
+        <p:nvSpPr>
+          <p:cNvPr id="6" name="Text 4"/>
+          <p:cNvSpPr/>
+          <p:nvPr/>
+        </p:nvSpPr>
+        <p:spPr>
+          <a:xfrm>
+            <a:off x="731520" y="1298448"/>
+            <a:ext cx="10698480" cy="457200"/>
+          </a:xfrm>
+          <a:prstGeom prst="rect">
+            <a:avLst/>
+          </a:prstGeom>
+          <a:noFill/>
+          <a:ln/>
+        </p:spPr>
+        <p:txBody>
+          <a:bodyPr wrap="square" lIns="0" tIns="0" rIns="0" bIns="0" rtlCol="0" anchor="ctr"/>
+          <a:lstStyle/>
+          <a:p>
+            <a:pPr indent="0" marL="0">
+              <a:buNone/>
+            </a:pPr>
+            <a:r>
+              <a:rPr lang="en-US" sz="1300" dirty="0">
+                <a:solidFill>
+                  <a:srgbClr val="0B1220"/>
+                </a:solidFill>
+                <a:latin typeface="Calibri" pitchFamily="34" charset="0"/>
+                <a:ea typeface="Calibri" pitchFamily="34" charset="-122"/>
+                <a:cs typeface="Calibri" pitchFamily="34" charset="-120"/>
+              </a:rPr>
+              <a:t>Pattern: one deployable service per domain. LedgeRX is the Ledger / Loyalty capability — not a monorepo of many ledgers, and not embedded inside CRM or POS.</a:t>
+            </a:r>
+            <a:endParaRPr lang="en-US" sz="1300" dirty="0"/>
+          </a:p>
+        </p:txBody>
+      </p:sp>
+      <p:sp>
+        <p:nvSpPr>
+          <p:cNvPr id="7" name="Shape 5"/>
+          <p:cNvSpPr/>
+          <p:nvPr/>
+        </p:nvSpPr>
+        <p:spPr>
+          <a:xfrm>
+            <a:off x="502920" y="2057400"/>
+            <a:ext cx="2880360" cy="822960"/>
+          </a:xfrm>
+          <a:prstGeom prst="roundRect">
+            <a:avLst>
+              <a:gd name="adj" fmla="val 6667"/>
             </a:avLst>
           </a:prstGeom>
           <a:solidFill>
@@ -3678,96 +3917,96 @@
       </p:sp>
       <p:sp>
         <p:nvSpPr>
-          <p:cNvPr id="6" name="Text 4"/>
-          <p:cNvSpPr/>
-          <p:nvPr/>
-        </p:nvSpPr>
-        <p:spPr>
-          <a:xfrm>
-            <a:off x="777240" y="1691640"/>
-            <a:ext cx="3063240" cy="411480"/>
-          </a:xfrm>
-          <a:prstGeom prst="rect">
-            <a:avLst/>
-          </a:prstGeom>
-          <a:noFill/>
-          <a:ln/>
-        </p:spPr>
-        <p:txBody>
-          <a:bodyPr wrap="square" lIns="0" tIns="0" rIns="0" bIns="0" rtlCol="0" anchor="ctr"/>
-          <a:lstStyle/>
-          <a:p>
-            <a:pPr indent="0" marL="0">
-              <a:buNone/>
-            </a:pPr>
-            <a:r>
-              <a:rPr lang="en-US" sz="1600" b="1" dirty="0">
-                <a:solidFill>
-                  <a:srgbClr val="0C2340"/>
-                </a:solidFill>
-                <a:latin typeface="Calibri" pitchFamily="34" charset="0"/>
-                <a:ea typeface="Calibri" pitchFamily="34" charset="-122"/>
-                <a:cs typeface="Calibri" pitchFamily="34" charset="-120"/>
-              </a:rPr>
-              <a:t>Time-to-rule</a:t>
-            </a:r>
-            <a:endParaRPr lang="en-US" sz="1600" dirty="0"/>
-          </a:p>
-        </p:txBody>
-      </p:sp>
-      <p:sp>
-        <p:nvSpPr>
-          <p:cNvPr id="7" name="Text 5"/>
-          <p:cNvSpPr/>
-          <p:nvPr/>
-        </p:nvSpPr>
-        <p:spPr>
-          <a:xfrm>
-            <a:off x="777240" y="2240280"/>
-            <a:ext cx="3063240" cy="914400"/>
-          </a:xfrm>
-          <a:prstGeom prst="rect">
-            <a:avLst/>
-          </a:prstGeom>
-          <a:noFill/>
-          <a:ln/>
-        </p:spPr>
-        <p:txBody>
-          <a:bodyPr wrap="square" lIns="0" tIns="0" rIns="0" bIns="0" rtlCol="0" anchor="ctr"/>
-          <a:lstStyle/>
-          <a:p>
-            <a:pPr indent="0" marL="0">
-              <a:buNone/>
-            </a:pPr>
-            <a:r>
-              <a:rPr lang="en-US" sz="1400" dirty="0">
-                <a:solidFill>
-                  <a:srgbClr val="334155"/>
-                </a:solidFill>
-                <a:latin typeface="Calibri" pitchFamily="34" charset="0"/>
-                <a:ea typeface="Calibri" pitchFamily="34" charset="-122"/>
-                <a:cs typeface="Calibri" pitchFamily="34" charset="-120"/>
-              </a:rPr>
-              <a:t>Change earn eligibility or rate in hours, not a release cycle.</a:t>
-            </a:r>
-            <a:endParaRPr lang="en-US" sz="1400" dirty="0"/>
-          </a:p>
-        </p:txBody>
-      </p:sp>
-      <p:sp>
-        <p:nvSpPr>
-          <p:cNvPr id="8" name="Shape 6"/>
-          <p:cNvSpPr/>
-          <p:nvPr/>
-        </p:nvSpPr>
-        <p:spPr>
-          <a:xfrm>
-            <a:off x="4343400" y="1325880"/>
-            <a:ext cx="3611880" cy="2103120"/>
+          <p:cNvPr id="8" name="Text 6"/>
+          <p:cNvSpPr/>
+          <p:nvPr/>
+        </p:nvSpPr>
+        <p:spPr>
+          <a:xfrm>
+            <a:off x="685800" y="2167128"/>
+            <a:ext cx="2560320" cy="411480"/>
+          </a:xfrm>
+          <a:prstGeom prst="rect">
+            <a:avLst/>
+          </a:prstGeom>
+          <a:noFill/>
+          <a:ln/>
+        </p:spPr>
+        <p:txBody>
+          <a:bodyPr wrap="square" lIns="0" tIns="0" rIns="0" bIns="0" rtlCol="0" anchor="ctr"/>
+          <a:lstStyle/>
+          <a:p>
+            <a:pPr indent="0" marL="0">
+              <a:buNone/>
+            </a:pPr>
+            <a:r>
+              <a:rPr lang="en-US" sz="1300" b="1" dirty="0">
+                <a:solidFill>
+                  <a:srgbClr val="0B1220"/>
+                </a:solidFill>
+                <a:latin typeface="Calibri" pitchFamily="34" charset="0"/>
+                <a:ea typeface="Calibri" pitchFamily="34" charset="-122"/>
+                <a:cs typeface="Calibri" pitchFamily="34" charset="-120"/>
+              </a:rPr>
+              <a:t>Identity / CRM</a:t>
+            </a:r>
+            <a:endParaRPr lang="en-US" sz="1300" dirty="0"/>
+          </a:p>
+        </p:txBody>
+      </p:sp>
+      <p:sp>
+        <p:nvSpPr>
+          <p:cNvPr id="9" name="Text 7"/>
+          <p:cNvSpPr/>
+          <p:nvPr/>
+        </p:nvSpPr>
+        <p:spPr>
+          <a:xfrm>
+            <a:off x="685800" y="2532888"/>
+            <a:ext cx="2560320" cy="256032"/>
+          </a:xfrm>
+          <a:prstGeom prst="rect">
+            <a:avLst/>
+          </a:prstGeom>
+          <a:noFill/>
+          <a:ln/>
+        </p:spPr>
+        <p:txBody>
+          <a:bodyPr wrap="square" lIns="0" tIns="0" rIns="0" bIns="0" rtlCol="0" anchor="ctr"/>
+          <a:lstStyle/>
+          <a:p>
+            <a:pPr indent="0" marL="0">
+              <a:buNone/>
+            </a:pPr>
+            <a:r>
+              <a:rPr lang="en-US" sz="1100" dirty="0">
+                <a:solidFill>
+                  <a:srgbClr val="64748B"/>
+                </a:solidFill>
+                <a:latin typeface="Calibri" pitchFamily="34" charset="0"/>
+                <a:ea typeface="Calibri" pitchFamily="34" charset="-122"/>
+                <a:cs typeface="Calibri" pitchFamily="34" charset="-120"/>
+              </a:rPr>
+              <a:t>ownerId source</a:t>
+            </a:r>
+            <a:endParaRPr lang="en-US" sz="1100" dirty="0"/>
+          </a:p>
+        </p:txBody>
+      </p:sp>
+      <p:sp>
+        <p:nvSpPr>
+          <p:cNvPr id="10" name="Shape 8"/>
+          <p:cNvSpPr/>
+          <p:nvPr/>
+        </p:nvSpPr>
+        <p:spPr>
+          <a:xfrm>
+            <a:off x="502920" y="3017520"/>
+            <a:ext cx="2880360" cy="822960"/>
           </a:xfrm>
           <a:prstGeom prst="roundRect">
             <a:avLst>
-              <a:gd name="adj" fmla="val 2609"/>
+              <a:gd name="adj" fmla="val 6667"/>
             </a:avLst>
           </a:prstGeom>
           <a:solidFill>
@@ -3785,96 +4024,113 @@
       </p:sp>
       <p:sp>
         <p:nvSpPr>
-          <p:cNvPr id="9" name="Text 7"/>
-          <p:cNvSpPr/>
-          <p:nvPr/>
-        </p:nvSpPr>
-        <p:spPr>
-          <a:xfrm>
-            <a:off x="4617720" y="1691640"/>
-            <a:ext cx="3063240" cy="411480"/>
-          </a:xfrm>
-          <a:prstGeom prst="rect">
-            <a:avLst/>
-          </a:prstGeom>
-          <a:noFill/>
-          <a:ln/>
-        </p:spPr>
-        <p:txBody>
-          <a:bodyPr wrap="square" lIns="0" tIns="0" rIns="0" bIns="0" rtlCol="0" anchor="ctr"/>
-          <a:lstStyle/>
-          <a:p>
-            <a:pPr indent="0" marL="0">
-              <a:buNone/>
-            </a:pPr>
-            <a:r>
-              <a:rPr lang="en-US" sz="1600" b="1" dirty="0">
-                <a:solidFill>
-                  <a:srgbClr val="0C2340"/>
-                </a:solidFill>
-                <a:latin typeface="Calibri" pitchFamily="34" charset="0"/>
-                <a:ea typeface="Calibri" pitchFamily="34" charset="-122"/>
-                <a:cs typeface="Calibri" pitchFamily="34" charset="-120"/>
-              </a:rPr>
-              <a:t>Finance confidence</a:t>
-            </a:r>
-            <a:endParaRPr lang="en-US" sz="1600" dirty="0"/>
-          </a:p>
-        </p:txBody>
-      </p:sp>
-      <p:sp>
-        <p:nvSpPr>
-          <p:cNvPr id="10" name="Text 8"/>
-          <p:cNvSpPr/>
-          <p:nvPr/>
-        </p:nvSpPr>
-        <p:spPr>
-          <a:xfrm>
-            <a:off x="4617720" y="2240280"/>
-            <a:ext cx="3063240" cy="914400"/>
-          </a:xfrm>
-          <a:prstGeom prst="rect">
-            <a:avLst/>
-          </a:prstGeom>
-          <a:noFill/>
-          <a:ln/>
-        </p:spPr>
-        <p:txBody>
-          <a:bodyPr wrap="square" lIns="0" tIns="0" rIns="0" bIns="0" rtlCol="0" anchor="ctr"/>
-          <a:lstStyle/>
-          <a:p>
-            <a:pPr indent="0" marL="0">
-              <a:buNone/>
-            </a:pPr>
-            <a:r>
-              <a:rPr lang="en-US" sz="1400" dirty="0">
-                <a:solidFill>
-                  <a:srgbClr val="334155"/>
-                </a:solidFill>
-                <a:latin typeface="Calibri" pitchFamily="34" charset="0"/>
-                <a:ea typeface="Calibri" pitchFamily="34" charset="-122"/>
-                <a:cs typeface="Calibri" pitchFamily="34" charset="-120"/>
-              </a:rPr>
-              <a:t>Every points movement is balanced double-entry with queryable legs.</a:t>
-            </a:r>
-            <a:endParaRPr lang="en-US" sz="1400" dirty="0"/>
-          </a:p>
-        </p:txBody>
-      </p:sp>
-      <p:sp>
-        <p:nvSpPr>
-          <p:cNvPr id="11" name="Shape 9"/>
-          <p:cNvSpPr/>
-          <p:nvPr/>
-        </p:nvSpPr>
-        <p:spPr>
-          <a:xfrm>
-            <a:off x="8183880" y="1325880"/>
-            <a:ext cx="3611880" cy="2103120"/>
+          <p:cNvPr id="11" name="Text 9"/>
+          <p:cNvSpPr/>
+          <p:nvPr/>
+        </p:nvSpPr>
+        <p:spPr>
+          <a:xfrm>
+            <a:off x="685800" y="3127248"/>
+            <a:ext cx="2560320" cy="411480"/>
+          </a:xfrm>
+          <a:prstGeom prst="rect">
+            <a:avLst/>
+          </a:prstGeom>
+          <a:noFill/>
+          <a:ln/>
+        </p:spPr>
+        <p:txBody>
+          <a:bodyPr wrap="square" lIns="0" tIns="0" rIns="0" bIns="0" rtlCol="0" anchor="ctr"/>
+          <a:lstStyle/>
+          <a:p>
+            <a:pPr indent="0" marL="0">
+              <a:buNone/>
+            </a:pPr>
+            <a:r>
+              <a:rPr lang="en-US" sz="1300" b="1" dirty="0">
+                <a:solidFill>
+                  <a:srgbClr val="0B1220"/>
+                </a:solidFill>
+                <a:latin typeface="Calibri" pitchFamily="34" charset="0"/>
+                <a:ea typeface="Calibri" pitchFamily="34" charset="-122"/>
+                <a:cs typeface="Calibri" pitchFamily="34" charset="-120"/>
+              </a:rPr>
+              <a:t>Channel / POS</a:t>
+            </a:r>
+            <a:endParaRPr lang="en-US" sz="1300" dirty="0"/>
+          </a:p>
+          <a:p>
+            <a:pPr indent="0" marL="0">
+              <a:buNone/>
+            </a:pPr>
+            <a:r>
+              <a:rPr lang="en-US" sz="1300" b="1" dirty="0">
+                <a:solidFill>
+                  <a:srgbClr val="0B1220"/>
+                </a:solidFill>
+                <a:latin typeface="Calibri" pitchFamily="34" charset="0"/>
+                <a:ea typeface="Calibri" pitchFamily="34" charset="-122"/>
+                <a:cs typeface="Calibri" pitchFamily="34" charset="-120"/>
+              </a:rPr>
+              <a:t>Gateway</a:t>
+            </a:r>
+            <a:endParaRPr lang="en-US" sz="1300" dirty="0"/>
+          </a:p>
+        </p:txBody>
+      </p:sp>
+      <p:sp>
+        <p:nvSpPr>
+          <p:cNvPr id="12" name="Text 10"/>
+          <p:cNvSpPr/>
+          <p:nvPr/>
+        </p:nvSpPr>
+        <p:spPr>
+          <a:xfrm>
+            <a:off x="685800" y="3493008"/>
+            <a:ext cx="2560320" cy="256032"/>
+          </a:xfrm>
+          <a:prstGeom prst="rect">
+            <a:avLst/>
+          </a:prstGeom>
+          <a:noFill/>
+          <a:ln/>
+        </p:spPr>
+        <p:txBody>
+          <a:bodyPr wrap="square" lIns="0" tIns="0" rIns="0" bIns="0" rtlCol="0" anchor="ctr"/>
+          <a:lstStyle/>
+          <a:p>
+            <a:pPr indent="0" marL="0">
+              <a:buNone/>
+            </a:pPr>
+            <a:r>
+              <a:rPr lang="en-US" sz="1100" dirty="0">
+                <a:solidFill>
+                  <a:srgbClr val="64748B"/>
+                </a:solidFill>
+                <a:latin typeface="Calibri" pitchFamily="34" charset="0"/>
+                <a:ea typeface="Calibri" pitchFamily="34" charset="-122"/>
+                <a:cs typeface="Calibri" pitchFamily="34" charset="-120"/>
+              </a:rPr>
+              <a:t>purchase events</a:t>
+            </a:r>
+            <a:endParaRPr lang="en-US" sz="1100" dirty="0"/>
+          </a:p>
+        </p:txBody>
+      </p:sp>
+      <p:sp>
+        <p:nvSpPr>
+          <p:cNvPr id="13" name="Shape 11"/>
+          <p:cNvSpPr/>
+          <p:nvPr/>
+        </p:nvSpPr>
+        <p:spPr>
+          <a:xfrm>
+            <a:off x="502920" y="3977640"/>
+            <a:ext cx="2880360" cy="822960"/>
           </a:xfrm>
           <a:prstGeom prst="roundRect">
             <a:avLst>
-              <a:gd name="adj" fmla="val 2609"/>
+              <a:gd name="adj" fmla="val 6667"/>
             </a:avLst>
           </a:prstGeom>
           <a:solidFill>
@@ -3892,96 +4148,113 @@
       </p:sp>
       <p:sp>
         <p:nvSpPr>
-          <p:cNvPr id="12" name="Text 10"/>
-          <p:cNvSpPr/>
-          <p:nvPr/>
-        </p:nvSpPr>
-        <p:spPr>
-          <a:xfrm>
-            <a:off x="8458200" y="1691640"/>
-            <a:ext cx="3063240" cy="411480"/>
-          </a:xfrm>
-          <a:prstGeom prst="rect">
-            <a:avLst/>
-          </a:prstGeom>
-          <a:noFill/>
-          <a:ln/>
-        </p:spPr>
-        <p:txBody>
-          <a:bodyPr wrap="square" lIns="0" tIns="0" rIns="0" bIns="0" rtlCol="0" anchor="ctr"/>
-          <a:lstStyle/>
-          <a:p>
-            <a:pPr indent="0" marL="0">
-              <a:buNone/>
-            </a:pPr>
-            <a:r>
-              <a:rPr lang="en-US" sz="1600" b="1" dirty="0">
-                <a:solidFill>
-                  <a:srgbClr val="0C2340"/>
-                </a:solidFill>
-                <a:latin typeface="Calibri" pitchFamily="34" charset="0"/>
-                <a:ea typeface="Calibri" pitchFamily="34" charset="-122"/>
-                <a:cs typeface="Calibri" pitchFamily="34" charset="-120"/>
-              </a:rPr>
-              <a:t>Channel leverage</a:t>
-            </a:r>
-            <a:endParaRPr lang="en-US" sz="1600" dirty="0"/>
-          </a:p>
-        </p:txBody>
-      </p:sp>
-      <p:sp>
-        <p:nvSpPr>
-          <p:cNvPr id="13" name="Text 11"/>
-          <p:cNvSpPr/>
-          <p:nvPr/>
-        </p:nvSpPr>
-        <p:spPr>
-          <a:xfrm>
-            <a:off x="8458200" y="2240280"/>
-            <a:ext cx="3063240" cy="914400"/>
-          </a:xfrm>
-          <a:prstGeom prst="rect">
-            <a:avLst/>
-          </a:prstGeom>
-          <a:noFill/>
-          <a:ln/>
-        </p:spPr>
-        <p:txBody>
-          <a:bodyPr wrap="square" lIns="0" tIns="0" rIns="0" bIns="0" rtlCol="0" anchor="ctr"/>
-          <a:lstStyle/>
-          <a:p>
-            <a:pPr indent="0" marL="0">
-              <a:buNone/>
-            </a:pPr>
-            <a:r>
-              <a:rPr lang="en-US" sz="1400" dirty="0">
-                <a:solidFill>
-                  <a:srgbClr val="334155"/>
-                </a:solidFill>
-                <a:latin typeface="Calibri" pitchFamily="34" charset="0"/>
-                <a:ea typeface="Calibri" pitchFamily="34" charset="-122"/>
-                <a:cs typeface="Calibri" pitchFamily="34" charset="-120"/>
-              </a:rPr>
-              <a:t>One event contract for POS, e-com, issuer — same Door/Brain/Books.</a:t>
-            </a:r>
-            <a:endParaRPr lang="en-US" sz="1400" dirty="0"/>
-          </a:p>
-        </p:txBody>
-      </p:sp>
-      <p:sp>
-        <p:nvSpPr>
-          <p:cNvPr id="14" name="Shape 12"/>
-          <p:cNvSpPr/>
-          <p:nvPr/>
-        </p:nvSpPr>
-        <p:spPr>
-          <a:xfrm>
-            <a:off x="502920" y="3657600"/>
-            <a:ext cx="3611880" cy="2103120"/>
+          <p:cNvPr id="14" name="Text 12"/>
+          <p:cNvSpPr/>
+          <p:nvPr/>
+        </p:nvSpPr>
+        <p:spPr>
+          <a:xfrm>
+            <a:off x="685800" y="4087368"/>
+            <a:ext cx="2560320" cy="411480"/>
+          </a:xfrm>
+          <a:prstGeom prst="rect">
+            <a:avLst/>
+          </a:prstGeom>
+          <a:noFill/>
+          <a:ln/>
+        </p:spPr>
+        <p:txBody>
+          <a:bodyPr wrap="square" lIns="0" tIns="0" rIns="0" bIns="0" rtlCol="0" anchor="ctr"/>
+          <a:lstStyle/>
+          <a:p>
+            <a:pPr indent="0" marL="0">
+              <a:buNone/>
+            </a:pPr>
+            <a:r>
+              <a:rPr lang="en-US" sz="1300" b="1" dirty="0">
+                <a:solidFill>
+                  <a:srgbClr val="0B1220"/>
+                </a:solidFill>
+                <a:latin typeface="Calibri" pitchFamily="34" charset="0"/>
+                <a:ea typeface="Calibri" pitchFamily="34" charset="-122"/>
+                <a:cs typeface="Calibri" pitchFamily="34" charset="-120"/>
+              </a:rPr>
+              <a:t>Card / Issuer</a:t>
+            </a:r>
+            <a:endParaRPr lang="en-US" sz="1300" dirty="0"/>
+          </a:p>
+          <a:p>
+            <a:pPr indent="0" marL="0">
+              <a:buNone/>
+            </a:pPr>
+            <a:r>
+              <a:rPr lang="en-US" sz="1300" b="1" dirty="0">
+                <a:solidFill>
+                  <a:srgbClr val="0B1220"/>
+                </a:solidFill>
+                <a:latin typeface="Calibri" pitchFamily="34" charset="0"/>
+                <a:ea typeface="Calibri" pitchFamily="34" charset="-122"/>
+                <a:cs typeface="Calibri" pitchFamily="34" charset="-120"/>
+              </a:rPr>
+              <a:t>Adapter</a:t>
+            </a:r>
+            <a:endParaRPr lang="en-US" sz="1300" dirty="0"/>
+          </a:p>
+        </p:txBody>
+      </p:sp>
+      <p:sp>
+        <p:nvSpPr>
+          <p:cNvPr id="15" name="Text 13"/>
+          <p:cNvSpPr/>
+          <p:nvPr/>
+        </p:nvSpPr>
+        <p:spPr>
+          <a:xfrm>
+            <a:off x="685800" y="4453128"/>
+            <a:ext cx="2560320" cy="256032"/>
+          </a:xfrm>
+          <a:prstGeom prst="rect">
+            <a:avLst/>
+          </a:prstGeom>
+          <a:noFill/>
+          <a:ln/>
+        </p:spPr>
+        <p:txBody>
+          <a:bodyPr wrap="square" lIns="0" tIns="0" rIns="0" bIns="0" rtlCol="0" anchor="ctr"/>
+          <a:lstStyle/>
+          <a:p>
+            <a:pPr indent="0" marL="0">
+              <a:buNone/>
+            </a:pPr>
+            <a:r>
+              <a:rPr lang="en-US" sz="1100" dirty="0">
+                <a:solidFill>
+                  <a:srgbClr val="64748B"/>
+                </a:solidFill>
+                <a:latin typeface="Calibri" pitchFamily="34" charset="0"/>
+                <a:ea typeface="Calibri" pitchFamily="34" charset="-122"/>
+                <a:cs typeface="Calibri" pitchFamily="34" charset="-120"/>
+              </a:rPr>
+              <a:t>auth · presentment</a:t>
+            </a:r>
+            <a:endParaRPr lang="en-US" sz="1100" dirty="0"/>
+          </a:p>
+        </p:txBody>
+      </p:sp>
+      <p:sp>
+        <p:nvSpPr>
+          <p:cNvPr id="16" name="Shape 14"/>
+          <p:cNvSpPr/>
+          <p:nvPr/>
+        </p:nvSpPr>
+        <p:spPr>
+          <a:xfrm>
+            <a:off x="502920" y="4937760"/>
+            <a:ext cx="2880360" cy="822960"/>
           </a:xfrm>
           <a:prstGeom prst="roundRect">
             <a:avLst>
-              <a:gd name="adj" fmla="val 2609"/>
+              <a:gd name="adj" fmla="val 6667"/>
             </a:avLst>
           </a:prstGeom>
           <a:solidFill>
@@ -3999,96 +4272,408 @@
       </p:sp>
       <p:sp>
         <p:nvSpPr>
-          <p:cNvPr id="15" name="Text 13"/>
-          <p:cNvSpPr/>
-          <p:nvPr/>
-        </p:nvSpPr>
-        <p:spPr>
-          <a:xfrm>
-            <a:off x="777240" y="4023360"/>
-            <a:ext cx="3063240" cy="411480"/>
-          </a:xfrm>
-          <a:prstGeom prst="rect">
-            <a:avLst/>
-          </a:prstGeom>
-          <a:noFill/>
-          <a:ln/>
-        </p:spPr>
-        <p:txBody>
-          <a:bodyPr wrap="square" lIns="0" tIns="0" rIns="0" bIns="0" rtlCol="0" anchor="ctr"/>
-          <a:lstStyle/>
-          <a:p>
-            <a:pPr indent="0" marL="0">
-              <a:buNone/>
-            </a:pPr>
-            <a:r>
-              <a:rPr lang="en-US" sz="1600" b="1" dirty="0">
-                <a:solidFill>
-                  <a:srgbClr val="0C2340"/>
-                </a:solidFill>
-                <a:latin typeface="Calibri" pitchFamily="34" charset="0"/>
-                <a:ea typeface="Calibri" pitchFamily="34" charset="-122"/>
-                <a:cs typeface="Calibri" pitchFamily="34" charset="-120"/>
-              </a:rPr>
-              <a:t>Operational clarity</a:t>
-            </a:r>
-            <a:endParaRPr lang="en-US" sz="1600" dirty="0"/>
-          </a:p>
-        </p:txBody>
-      </p:sp>
-      <p:sp>
-        <p:nvSpPr>
-          <p:cNvPr id="16" name="Text 14"/>
-          <p:cNvSpPr/>
-          <p:nvPr/>
-        </p:nvSpPr>
-        <p:spPr>
-          <a:xfrm>
-            <a:off x="777240" y="4572000"/>
-            <a:ext cx="3063240" cy="914400"/>
-          </a:xfrm>
-          <a:prstGeom prst="rect">
-            <a:avLst/>
-          </a:prstGeom>
-          <a:noFill/>
-          <a:ln/>
-        </p:spPr>
-        <p:txBody>
-          <a:bodyPr wrap="square" lIns="0" tIns="0" rIns="0" bIns="0" rtlCol="0" anchor="ctr"/>
-          <a:lstStyle/>
-          <a:p>
-            <a:pPr indent="0" marL="0">
-              <a:buNone/>
-            </a:pPr>
-            <a:r>
-              <a:rPr lang="en-US" sz="1400" dirty="0">
-                <a:solidFill>
-                  <a:srgbClr val="334155"/>
-                </a:solidFill>
-                <a:latin typeface="Calibri" pitchFamily="34" charset="0"/>
-                <a:ea typeface="Calibri" pitchFamily="34" charset="-122"/>
-                <a:cs typeface="Calibri" pitchFamily="34" charset="-120"/>
-              </a:rPr>
-              <a:t>Dry-run and skip traces reduce ‘why no points?’ tickets.</a:t>
-            </a:r>
-            <a:endParaRPr lang="en-US" sz="1400" dirty="0"/>
-          </a:p>
-        </p:txBody>
-      </p:sp>
-      <p:sp>
-        <p:nvSpPr>
-          <p:cNvPr id="17" name="Shape 15"/>
-          <p:cNvSpPr/>
-          <p:nvPr/>
-        </p:nvSpPr>
-        <p:spPr>
-          <a:xfrm>
-            <a:off x="4343400" y="3657600"/>
-            <a:ext cx="3611880" cy="2103120"/>
+          <p:cNvPr id="17" name="Text 15"/>
+          <p:cNvSpPr/>
+          <p:nvPr/>
+        </p:nvSpPr>
+        <p:spPr>
+          <a:xfrm>
+            <a:off x="685800" y="5047488"/>
+            <a:ext cx="2560320" cy="411480"/>
+          </a:xfrm>
+          <a:prstGeom prst="rect">
+            <a:avLst/>
+          </a:prstGeom>
+          <a:noFill/>
+          <a:ln/>
+        </p:spPr>
+        <p:txBody>
+          <a:bodyPr wrap="square" lIns="0" tIns="0" rIns="0" bIns="0" rtlCol="0" anchor="ctr"/>
+          <a:lstStyle/>
+          <a:p>
+            <a:pPr indent="0" marL="0">
+              <a:buNone/>
+            </a:pPr>
+            <a:r>
+              <a:rPr lang="en-US" sz="1300" b="1" dirty="0">
+                <a:solidFill>
+                  <a:srgbClr val="0B1220"/>
+                </a:solidFill>
+                <a:latin typeface="Calibri" pitchFamily="34" charset="0"/>
+                <a:ea typeface="Calibri" pitchFamily="34" charset="-122"/>
+                <a:cs typeface="Calibri" pitchFamily="34" charset="-120"/>
+              </a:rPr>
+              <a:t>Notification</a:t>
+            </a:r>
+            <a:endParaRPr lang="en-US" sz="1300" dirty="0"/>
+          </a:p>
+          <a:p>
+            <a:pPr indent="0" marL="0">
+              <a:buNone/>
+            </a:pPr>
+            <a:r>
+              <a:rPr lang="en-US" sz="1300" b="1" dirty="0">
+                <a:solidFill>
+                  <a:srgbClr val="0B1220"/>
+                </a:solidFill>
+                <a:latin typeface="Calibri" pitchFamily="34" charset="0"/>
+                <a:ea typeface="Calibri" pitchFamily="34" charset="-122"/>
+                <a:cs typeface="Calibri" pitchFamily="34" charset="-120"/>
+              </a:rPr>
+              <a:t>(optional)</a:t>
+            </a:r>
+            <a:endParaRPr lang="en-US" sz="1300" dirty="0"/>
+          </a:p>
+        </p:txBody>
+      </p:sp>
+      <p:sp>
+        <p:nvSpPr>
+          <p:cNvPr id="18" name="Text 16"/>
+          <p:cNvSpPr/>
+          <p:nvPr/>
+        </p:nvSpPr>
+        <p:spPr>
+          <a:xfrm>
+            <a:off x="685800" y="5413248"/>
+            <a:ext cx="2560320" cy="256032"/>
+          </a:xfrm>
+          <a:prstGeom prst="rect">
+            <a:avLst/>
+          </a:prstGeom>
+          <a:noFill/>
+          <a:ln/>
+        </p:spPr>
+        <p:txBody>
+          <a:bodyPr wrap="square" lIns="0" tIns="0" rIns="0" bIns="0" rtlCol="0" anchor="ctr"/>
+          <a:lstStyle/>
+          <a:p>
+            <a:pPr indent="0" marL="0">
+              <a:buNone/>
+            </a:pPr>
+            <a:r>
+              <a:rPr lang="en-US" sz="1100" dirty="0">
+                <a:solidFill>
+                  <a:srgbClr val="64748B"/>
+                </a:solidFill>
+                <a:latin typeface="Calibri" pitchFamily="34" charset="0"/>
+                <a:ea typeface="Calibri" pitchFamily="34" charset="-122"/>
+                <a:cs typeface="Calibri" pitchFamily="34" charset="-120"/>
+              </a:rPr>
+              <a:t>balance alerts</a:t>
+            </a:r>
+            <a:endParaRPr lang="en-US" sz="1100" dirty="0"/>
+          </a:p>
+        </p:txBody>
+      </p:sp>
+      <p:sp>
+        <p:nvSpPr>
+          <p:cNvPr id="19" name="Shape 17"/>
+          <p:cNvSpPr/>
+          <p:nvPr/>
+        </p:nvSpPr>
+        <p:spPr>
+          <a:xfrm>
+            <a:off x="3840480" y="2057400"/>
+            <a:ext cx="4480560" cy="3794760"/>
           </a:xfrm>
           <a:prstGeom prst="roundRect">
             <a:avLst>
-              <a:gd name="adj" fmla="val 2609"/>
+              <a:gd name="adj" fmla="val 2410"/>
+            </a:avLst>
+          </a:prstGeom>
+          <a:solidFill>
+            <a:srgbClr val="0C2340"/>
+          </a:solidFill>
+          <a:ln/>
+        </p:spPr>
+      </p:sp>
+      <p:sp>
+        <p:nvSpPr>
+          <p:cNvPr id="20" name="Text 18"/>
+          <p:cNvSpPr/>
+          <p:nvPr/>
+        </p:nvSpPr>
+        <p:spPr>
+          <a:xfrm>
+            <a:off x="3840480" y="2331720"/>
+            <a:ext cx="4480560" cy="411480"/>
+          </a:xfrm>
+          <a:prstGeom prst="rect">
+            <a:avLst/>
+          </a:prstGeom>
+          <a:noFill/>
+          <a:ln/>
+        </p:spPr>
+        <p:txBody>
+          <a:bodyPr wrap="square" lIns="0" tIns="0" rIns="0" bIns="0" rtlCol="0" anchor="ctr"/>
+          <a:lstStyle/>
+          <a:p>
+            <a:pPr algn="ctr" indent="0" marL="0">
+              <a:buNone/>
+            </a:pPr>
+            <a:r>
+              <a:rPr lang="en-US" sz="2200" b="1" dirty="0">
+                <a:solidFill>
+                  <a:srgbClr val="FFFFFF"/>
+                </a:solidFill>
+                <a:latin typeface="Calibri" pitchFamily="34" charset="0"/>
+                <a:ea typeface="Calibri" pitchFamily="34" charset="-122"/>
+                <a:cs typeface="Calibri" pitchFamily="34" charset="-120"/>
+              </a:rPr>
+              <a:t>LedgeRX</a:t>
+            </a:r>
+            <a:endParaRPr lang="en-US" sz="2200" dirty="0"/>
+          </a:p>
+        </p:txBody>
+      </p:sp>
+      <p:sp>
+        <p:nvSpPr>
+          <p:cNvPr id="21" name="Text 19"/>
+          <p:cNvSpPr/>
+          <p:nvPr/>
+        </p:nvSpPr>
+        <p:spPr>
+          <a:xfrm>
+            <a:off x="3840480" y="2788920"/>
+            <a:ext cx="4480560" cy="274320"/>
+          </a:xfrm>
+          <a:prstGeom prst="rect">
+            <a:avLst/>
+          </a:prstGeom>
+          <a:noFill/>
+          <a:ln/>
+        </p:spPr>
+        <p:txBody>
+          <a:bodyPr wrap="square" lIns="0" tIns="0" rIns="0" bIns="0" rtlCol="0" anchor="ctr"/>
+          <a:lstStyle/>
+          <a:p>
+            <a:pPr algn="ctr" indent="0" marL="0">
+              <a:buNone/>
+            </a:pPr>
+            <a:r>
+              <a:rPr lang="en-US" sz="1300" dirty="0">
+                <a:solidFill>
+                  <a:srgbClr val="0F766E"/>
+                </a:solidFill>
+                <a:latin typeface="Calibri" pitchFamily="34" charset="0"/>
+                <a:ea typeface="Calibri" pitchFamily="34" charset="-122"/>
+                <a:cs typeface="Calibri" pitchFamily="34" charset="-120"/>
+              </a:rPr>
+              <a:t>ledger-engine</a:t>
+            </a:r>
+            <a:endParaRPr lang="en-US" sz="1300" dirty="0"/>
+          </a:p>
+        </p:txBody>
+      </p:sp>
+      <p:sp>
+        <p:nvSpPr>
+          <p:cNvPr id="22" name="Text 20"/>
+          <p:cNvSpPr/>
+          <p:nvPr/>
+        </p:nvSpPr>
+        <p:spPr>
+          <a:xfrm>
+            <a:off x="4114800" y="3200400"/>
+            <a:ext cx="3931920" cy="274320"/>
+          </a:xfrm>
+          <a:prstGeom prst="rect">
+            <a:avLst/>
+          </a:prstGeom>
+          <a:noFill/>
+          <a:ln/>
+        </p:spPr>
+        <p:txBody>
+          <a:bodyPr wrap="square" lIns="0" tIns="0" rIns="0" bIns="0" rtlCol="0" anchor="ctr"/>
+          <a:lstStyle/>
+          <a:p>
+            <a:pPr algn="ctr" indent="0" marL="0">
+              <a:buNone/>
+            </a:pPr>
+            <a:r>
+              <a:rPr lang="en-US" sz="1200" dirty="0">
+                <a:solidFill>
+                  <a:srgbClr val="94A3B8"/>
+                </a:solidFill>
+                <a:latin typeface="Calibri" pitchFamily="34" charset="0"/>
+                <a:ea typeface="Calibri" pitchFamily="34" charset="-122"/>
+                <a:cs typeface="Calibri" pitchFamily="34" charset="-120"/>
+              </a:rPr>
+              <a:t>Domain microservice</a:t>
+            </a:r>
+            <a:endParaRPr lang="en-US" sz="1200" dirty="0"/>
+          </a:p>
+        </p:txBody>
+      </p:sp>
+      <p:sp>
+        <p:nvSpPr>
+          <p:cNvPr id="23" name="Text 21"/>
+          <p:cNvSpPr/>
+          <p:nvPr/>
+        </p:nvSpPr>
+        <p:spPr>
+          <a:xfrm>
+            <a:off x="4297680" y="3657600"/>
+            <a:ext cx="3749040" cy="365760"/>
+          </a:xfrm>
+          <a:prstGeom prst="rect">
+            <a:avLst/>
+          </a:prstGeom>
+          <a:noFill/>
+          <a:ln/>
+        </p:spPr>
+        <p:txBody>
+          <a:bodyPr wrap="square" lIns="0" tIns="0" rIns="0" bIns="0" rtlCol="0" anchor="ctr"/>
+          <a:lstStyle/>
+          <a:p>
+            <a:pPr indent="0" marL="0">
+              <a:buNone/>
+            </a:pPr>
+            <a:r>
+              <a:rPr lang="en-US" sz="1300" dirty="0">
+                <a:solidFill>
+                  <a:srgbClr val="E2E8F0"/>
+                </a:solidFill>
+                <a:latin typeface="Calibri" pitchFamily="34" charset="0"/>
+                <a:ea typeface="Calibri" pitchFamily="34" charset="-122"/>
+                <a:cs typeface="Calibri" pitchFamily="34" charset="-120"/>
+              </a:rPr>
+              <a:t>·  HTTP product APIs (ClusterIP)</a:t>
+            </a:r>
+            <a:endParaRPr lang="en-US" sz="1300" dirty="0"/>
+          </a:p>
+        </p:txBody>
+      </p:sp>
+      <p:sp>
+        <p:nvSpPr>
+          <p:cNvPr id="24" name="Text 22"/>
+          <p:cNvSpPr/>
+          <p:nvPr/>
+        </p:nvSpPr>
+        <p:spPr>
+          <a:xfrm>
+            <a:off x="4297680" y="4069080"/>
+            <a:ext cx="3749040" cy="365760"/>
+          </a:xfrm>
+          <a:prstGeom prst="rect">
+            <a:avLst/>
+          </a:prstGeom>
+          <a:noFill/>
+          <a:ln/>
+        </p:spPr>
+        <p:txBody>
+          <a:bodyPr wrap="square" lIns="0" tIns="0" rIns="0" bIns="0" rtlCol="0" anchor="ctr"/>
+          <a:lstStyle/>
+          <a:p>
+            <a:pPr indent="0" marL="0">
+              <a:buNone/>
+            </a:pPr>
+            <a:r>
+              <a:rPr lang="en-US" sz="1300" dirty="0">
+                <a:solidFill>
+                  <a:srgbClr val="E2E8F0"/>
+                </a:solidFill>
+                <a:latin typeface="Calibri" pitchFamily="34" charset="0"/>
+                <a:ea typeface="Calibri" pitchFamily="34" charset="-122"/>
+                <a:cs typeface="Calibri" pitchFamily="34" charset="-120"/>
+              </a:rPr>
+              <a:t>·  Door · Brain · Books · COA</a:t>
+            </a:r>
+            <a:endParaRPr lang="en-US" sz="1300" dirty="0"/>
+          </a:p>
+        </p:txBody>
+      </p:sp>
+      <p:sp>
+        <p:nvSpPr>
+          <p:cNvPr id="25" name="Text 23"/>
+          <p:cNvSpPr/>
+          <p:nvPr/>
+        </p:nvSpPr>
+        <p:spPr>
+          <a:xfrm>
+            <a:off x="4297680" y="4480560"/>
+            <a:ext cx="3749040" cy="365760"/>
+          </a:xfrm>
+          <a:prstGeom prst="rect">
+            <a:avLst/>
+          </a:prstGeom>
+          <a:noFill/>
+          <a:ln/>
+        </p:spPr>
+        <p:txBody>
+          <a:bodyPr wrap="square" lIns="0" tIns="0" rIns="0" bIns="0" rtlCol="0" anchor="ctr"/>
+          <a:lstStyle/>
+          <a:p>
+            <a:pPr indent="0" marL="0">
+              <a:buNone/>
+            </a:pPr>
+            <a:r>
+              <a:rPr lang="en-US" sz="1300" dirty="0">
+                <a:solidFill>
+                  <a:srgbClr val="E2E8F0"/>
+                </a:solidFill>
+                <a:latin typeface="Calibri" pitchFamily="34" charset="0"/>
+                <a:ea typeface="Calibri" pitchFamily="34" charset="-122"/>
+                <a:cs typeface="Calibri" pitchFamily="34" charset="-120"/>
+              </a:rPr>
+              <a:t>·  Own PostgreSQL schema</a:t>
+            </a:r>
+            <a:endParaRPr lang="en-US" sz="1300" dirty="0"/>
+          </a:p>
+        </p:txBody>
+      </p:sp>
+      <p:sp>
+        <p:nvSpPr>
+          <p:cNvPr id="26" name="Text 24"/>
+          <p:cNvSpPr/>
+          <p:nvPr/>
+        </p:nvSpPr>
+        <p:spPr>
+          <a:xfrm>
+            <a:off x="4297680" y="4892040"/>
+            <a:ext cx="3749040" cy="365760"/>
+          </a:xfrm>
+          <a:prstGeom prst="rect">
+            <a:avLst/>
+          </a:prstGeom>
+          <a:noFill/>
+          <a:ln/>
+        </p:spPr>
+        <p:txBody>
+          <a:bodyPr wrap="square" lIns="0" tIns="0" rIns="0" bIns="0" rtlCol="0" anchor="ctr"/>
+          <a:lstStyle/>
+          <a:p>
+            <a:pPr indent="0" marL="0">
+              <a:buNone/>
+            </a:pPr>
+            <a:r>
+              <a:rPr lang="en-US" sz="1300" dirty="0">
+                <a:solidFill>
+                  <a:srgbClr val="E2E8F0"/>
+                </a:solidFill>
+                <a:latin typeface="Calibri" pitchFamily="34" charset="0"/>
+                <a:ea typeface="Calibri" pitchFamily="34" charset="-122"/>
+                <a:cs typeface="Calibri" pitchFamily="34" charset="-120"/>
+              </a:rPr>
+              <a:t>·  Admin UI as separate BFF</a:t>
+            </a:r>
+            <a:endParaRPr lang="en-US" sz="1300" dirty="0"/>
+          </a:p>
+        </p:txBody>
+      </p:sp>
+      <p:sp>
+        <p:nvSpPr>
+          <p:cNvPr id="27" name="Shape 25"/>
+          <p:cNvSpPr/>
+          <p:nvPr/>
+        </p:nvSpPr>
+        <p:spPr>
+          <a:xfrm>
+            <a:off x="8732520" y="2057400"/>
+            <a:ext cx="2926080" cy="822960"/>
+          </a:xfrm>
+          <a:prstGeom prst="roundRect">
+            <a:avLst>
+              <a:gd name="adj" fmla="val 6667"/>
             </a:avLst>
           </a:prstGeom>
           <a:solidFill>
@@ -4106,96 +4691,113 @@
       </p:sp>
       <p:sp>
         <p:nvSpPr>
-          <p:cNvPr id="18" name="Text 16"/>
-          <p:cNvSpPr/>
-          <p:nvPr/>
-        </p:nvSpPr>
-        <p:spPr>
-          <a:xfrm>
-            <a:off x="4617720" y="4023360"/>
-            <a:ext cx="3063240" cy="411480"/>
-          </a:xfrm>
-          <a:prstGeom prst="rect">
-            <a:avLst/>
-          </a:prstGeom>
-          <a:noFill/>
-          <a:ln/>
-        </p:spPr>
-        <p:txBody>
-          <a:bodyPr wrap="square" lIns="0" tIns="0" rIns="0" bIns="0" rtlCol="0" anchor="ctr"/>
-          <a:lstStyle/>
-          <a:p>
-            <a:pPr indent="0" marL="0">
-              <a:buNone/>
-            </a:pPr>
-            <a:r>
-              <a:rPr lang="en-US" sz="1600" b="1" dirty="0">
-                <a:solidFill>
-                  <a:srgbClr val="0C2340"/>
-                </a:solidFill>
-                <a:latin typeface="Calibri" pitchFamily="34" charset="0"/>
-                <a:ea typeface="Calibri" pitchFamily="34" charset="-122"/>
-                <a:cs typeface="Calibri" pitchFamily="34" charset="-120"/>
-              </a:rPr>
-              <a:t>Clean boundaries</a:t>
-            </a:r>
-            <a:endParaRPr lang="en-US" sz="1600" dirty="0"/>
-          </a:p>
-        </p:txBody>
-      </p:sp>
-      <p:sp>
-        <p:nvSpPr>
-          <p:cNvPr id="19" name="Text 17"/>
-          <p:cNvSpPr/>
-          <p:nvPr/>
-        </p:nvSpPr>
-        <p:spPr>
-          <a:xfrm>
-            <a:off x="4617720" y="4572000"/>
-            <a:ext cx="3063240" cy="914400"/>
-          </a:xfrm>
-          <a:prstGeom prst="rect">
-            <a:avLst/>
-          </a:prstGeom>
-          <a:noFill/>
-          <a:ln/>
-        </p:spPr>
-        <p:txBody>
-          <a:bodyPr wrap="square" lIns="0" tIns="0" rIns="0" bIns="0" rtlCol="0" anchor="ctr"/>
-          <a:lstStyle/>
-          <a:p>
-            <a:pPr indent="0" marL="0">
-              <a:buNone/>
-            </a:pPr>
-            <a:r>
-              <a:rPr lang="en-US" sz="1400" dirty="0">
-                <a:solidFill>
-                  <a:srgbClr val="334155"/>
-                </a:solidFill>
-                <a:latin typeface="Calibri" pitchFamily="34" charset="0"/>
-                <a:ea typeface="Calibri" pitchFamily="34" charset="-122"/>
-                <a:cs typeface="Calibri" pitchFamily="34" charset="-120"/>
-              </a:rPr>
-              <a:t>CRM stays CRM; payments stay payments; ledger stays ledger.</a:t>
-            </a:r>
-            <a:endParaRPr lang="en-US" sz="1400" dirty="0"/>
-          </a:p>
-        </p:txBody>
-      </p:sp>
-      <p:sp>
-        <p:nvSpPr>
-          <p:cNvPr id="20" name="Shape 18"/>
-          <p:cNvSpPr/>
-          <p:nvPr/>
-        </p:nvSpPr>
-        <p:spPr>
-          <a:xfrm>
-            <a:off x="8183880" y="3657600"/>
-            <a:ext cx="3611880" cy="2103120"/>
+          <p:cNvPr id="28" name="Text 26"/>
+          <p:cNvSpPr/>
+          <p:nvPr/>
+        </p:nvSpPr>
+        <p:spPr>
+          <a:xfrm>
+            <a:off x="8915400" y="2167128"/>
+            <a:ext cx="2606040" cy="411480"/>
+          </a:xfrm>
+          <a:prstGeom prst="rect">
+            <a:avLst/>
+          </a:prstGeom>
+          <a:noFill/>
+          <a:ln/>
+        </p:spPr>
+        <p:txBody>
+          <a:bodyPr wrap="square" lIns="0" tIns="0" rIns="0" bIns="0" rtlCol="0" anchor="ctr"/>
+          <a:lstStyle/>
+          <a:p>
+            <a:pPr indent="0" marL="0">
+              <a:buNone/>
+            </a:pPr>
+            <a:r>
+              <a:rPr lang="en-US" sz="1300" b="1" dirty="0">
+                <a:solidFill>
+                  <a:srgbClr val="0B1220"/>
+                </a:solidFill>
+                <a:latin typeface="Calibri" pitchFamily="34" charset="0"/>
+                <a:ea typeface="Calibri" pitchFamily="34" charset="-122"/>
+                <a:cs typeface="Calibri" pitchFamily="34" charset="-120"/>
+              </a:rPr>
+              <a:t>API Gateway /</a:t>
+            </a:r>
+            <a:endParaRPr lang="en-US" sz="1300" dirty="0"/>
+          </a:p>
+          <a:p>
+            <a:pPr indent="0" marL="0">
+              <a:buNone/>
+            </a:pPr>
+            <a:r>
+              <a:rPr lang="en-US" sz="1300" b="1" dirty="0">
+                <a:solidFill>
+                  <a:srgbClr val="0B1220"/>
+                </a:solidFill>
+                <a:latin typeface="Calibri" pitchFamily="34" charset="0"/>
+                <a:ea typeface="Calibri" pitchFamily="34" charset="-122"/>
+                <a:cs typeface="Calibri" pitchFamily="34" charset="-120"/>
+              </a:rPr>
+              <a:t>Mesh</a:t>
+            </a:r>
+            <a:endParaRPr lang="en-US" sz="1300" dirty="0"/>
+          </a:p>
+        </p:txBody>
+      </p:sp>
+      <p:sp>
+        <p:nvSpPr>
+          <p:cNvPr id="29" name="Text 27"/>
+          <p:cNvSpPr/>
+          <p:nvPr/>
+        </p:nvSpPr>
+        <p:spPr>
+          <a:xfrm>
+            <a:off x="8915400" y="2532888"/>
+            <a:ext cx="2606040" cy="256032"/>
+          </a:xfrm>
+          <a:prstGeom prst="rect">
+            <a:avLst/>
+          </a:prstGeom>
+          <a:noFill/>
+          <a:ln/>
+        </p:spPr>
+        <p:txBody>
+          <a:bodyPr wrap="square" lIns="0" tIns="0" rIns="0" bIns="0" rtlCol="0" anchor="ctr"/>
+          <a:lstStyle/>
+          <a:p>
+            <a:pPr indent="0" marL="0">
+              <a:buNone/>
+            </a:pPr>
+            <a:r>
+              <a:rPr lang="en-US" sz="1100" dirty="0">
+                <a:solidFill>
+                  <a:srgbClr val="64748B"/>
+                </a:solidFill>
+                <a:latin typeface="Calibri" pitchFamily="34" charset="0"/>
+                <a:ea typeface="Calibri" pitchFamily="34" charset="-122"/>
+                <a:cs typeface="Calibri" pitchFamily="34" charset="-120"/>
+              </a:rPr>
+              <a:t>internal routing</a:t>
+            </a:r>
+            <a:endParaRPr lang="en-US" sz="1100" dirty="0"/>
+          </a:p>
+        </p:txBody>
+      </p:sp>
+      <p:sp>
+        <p:nvSpPr>
+          <p:cNvPr id="30" name="Shape 28"/>
+          <p:cNvSpPr/>
+          <p:nvPr/>
+        </p:nvSpPr>
+        <p:spPr>
+          <a:xfrm>
+            <a:off x="8732520" y="3017520"/>
+            <a:ext cx="2926080" cy="822960"/>
           </a:xfrm>
           <a:prstGeom prst="roundRect">
             <a:avLst>
-              <a:gd name="adj" fmla="val 2609"/>
+              <a:gd name="adj" fmla="val 6667"/>
             </a:avLst>
           </a:prstGeom>
           <a:solidFill>
@@ -4213,85 +4815,355 @@
       </p:sp>
       <p:sp>
         <p:nvSpPr>
-          <p:cNvPr id="21" name="Text 19"/>
-          <p:cNvSpPr/>
-          <p:nvPr/>
-        </p:nvSpPr>
-        <p:spPr>
-          <a:xfrm>
-            <a:off x="8458200" y="4023360"/>
-            <a:ext cx="3063240" cy="411480"/>
-          </a:xfrm>
-          <a:prstGeom prst="rect">
-            <a:avLst/>
-          </a:prstGeom>
-          <a:noFill/>
-          <a:ln/>
-        </p:spPr>
-        <p:txBody>
-          <a:bodyPr wrap="square" lIns="0" tIns="0" rIns="0" bIns="0" rtlCol="0" anchor="ctr"/>
-          <a:lstStyle/>
-          <a:p>
-            <a:pPr indent="0" marL="0">
-              <a:buNone/>
-            </a:pPr>
-            <a:r>
-              <a:rPr lang="en-US" sz="1600" b="1" dirty="0">
-                <a:solidFill>
-                  <a:srgbClr val="0C2340"/>
-                </a:solidFill>
-                <a:latin typeface="Calibri" pitchFamily="34" charset="0"/>
-                <a:ea typeface="Calibri" pitchFamily="34" charset="-122"/>
-                <a:cs typeface="Calibri" pitchFamily="34" charset="-120"/>
-              </a:rPr>
-              <a:t>Deployment fit</a:t>
-            </a:r>
-            <a:endParaRPr lang="en-US" sz="1600" dirty="0"/>
-          </a:p>
-        </p:txBody>
-      </p:sp>
-      <p:sp>
-        <p:nvSpPr>
-          <p:cNvPr id="22" name="Text 20"/>
-          <p:cNvSpPr/>
-          <p:nvPr/>
-        </p:nvSpPr>
-        <p:spPr>
-          <a:xfrm>
-            <a:off x="8458200" y="4572000"/>
-            <a:ext cx="3063240" cy="914400"/>
-          </a:xfrm>
-          <a:prstGeom prst="rect">
-            <a:avLst/>
-          </a:prstGeom>
-          <a:noFill/>
-          <a:ln/>
-        </p:spPr>
-        <p:txBody>
-          <a:bodyPr wrap="square" lIns="0" tIns="0" rIns="0" bIns="0" rtlCol="0" anchor="ctr"/>
-          <a:lstStyle/>
-          <a:p>
-            <a:pPr indent="0" marL="0">
-              <a:buNone/>
-            </a:pPr>
-            <a:r>
-              <a:rPr lang="en-US" sz="1400" dirty="0">
-                <a:solidFill>
-                  <a:srgbClr val="334155"/>
-                </a:solidFill>
-                <a:latin typeface="Calibri" pitchFamily="34" charset="0"/>
-                <a:ea typeface="Calibri" pitchFamily="34" charset="-122"/>
-                <a:cs typeface="Calibri" pitchFamily="34" charset="-120"/>
-              </a:rPr>
-              <a:t>Runs inside the client cluster — data residency and network control.</a:t>
-            </a:r>
-            <a:endParaRPr lang="en-US" sz="1400" dirty="0"/>
-          </a:p>
-        </p:txBody>
-      </p:sp>
-      <p:sp>
-        <p:nvSpPr>
-          <p:cNvPr id="23" name="Text 21"/>
+          <p:cNvPr id="31" name="Text 29"/>
+          <p:cNvSpPr/>
+          <p:nvPr/>
+        </p:nvSpPr>
+        <p:spPr>
+          <a:xfrm>
+            <a:off x="8915400" y="3127248"/>
+            <a:ext cx="2606040" cy="411480"/>
+          </a:xfrm>
+          <a:prstGeom prst="rect">
+            <a:avLst/>
+          </a:prstGeom>
+          <a:noFill/>
+          <a:ln/>
+        </p:spPr>
+        <p:txBody>
+          <a:bodyPr wrap="square" lIns="0" tIns="0" rIns="0" bIns="0" rtlCol="0" anchor="ctr"/>
+          <a:lstStyle/>
+          <a:p>
+            <a:pPr indent="0" marL="0">
+              <a:buNone/>
+            </a:pPr>
+            <a:r>
+              <a:rPr lang="en-US" sz="1300" b="1" dirty="0">
+                <a:solidFill>
+                  <a:srgbClr val="0B1220"/>
+                </a:solidFill>
+                <a:latin typeface="Calibri" pitchFamily="34" charset="0"/>
+                <a:ea typeface="Calibri" pitchFamily="34" charset="-122"/>
+                <a:cs typeface="Calibri" pitchFamily="34" charset="-120"/>
+              </a:rPr>
+              <a:t>Config / Secrets</a:t>
+            </a:r>
+            <a:endParaRPr lang="en-US" sz="1300" dirty="0"/>
+          </a:p>
+        </p:txBody>
+      </p:sp>
+      <p:sp>
+        <p:nvSpPr>
+          <p:cNvPr id="32" name="Text 30"/>
+          <p:cNvSpPr/>
+          <p:nvPr/>
+        </p:nvSpPr>
+        <p:spPr>
+          <a:xfrm>
+            <a:off x="8915400" y="3493008"/>
+            <a:ext cx="2606040" cy="256032"/>
+          </a:xfrm>
+          <a:prstGeom prst="rect">
+            <a:avLst/>
+          </a:prstGeom>
+          <a:noFill/>
+          <a:ln/>
+        </p:spPr>
+        <p:txBody>
+          <a:bodyPr wrap="square" lIns="0" tIns="0" rIns="0" bIns="0" rtlCol="0" anchor="ctr"/>
+          <a:lstStyle/>
+          <a:p>
+            <a:pPr indent="0" marL="0">
+              <a:buNone/>
+            </a:pPr>
+            <a:r>
+              <a:rPr lang="en-US" sz="1100" dirty="0">
+                <a:solidFill>
+                  <a:srgbClr val="64748B"/>
+                </a:solidFill>
+                <a:latin typeface="Calibri" pitchFamily="34" charset="0"/>
+                <a:ea typeface="Calibri" pitchFamily="34" charset="-122"/>
+                <a:cs typeface="Calibri" pitchFamily="34" charset="-120"/>
+              </a:rPr>
+              <a:t>env · later API key</a:t>
+            </a:r>
+            <a:endParaRPr lang="en-US" sz="1100" dirty="0"/>
+          </a:p>
+        </p:txBody>
+      </p:sp>
+      <p:sp>
+        <p:nvSpPr>
+          <p:cNvPr id="33" name="Shape 31"/>
+          <p:cNvSpPr/>
+          <p:nvPr/>
+        </p:nvSpPr>
+        <p:spPr>
+          <a:xfrm>
+            <a:off x="8732520" y="3977640"/>
+            <a:ext cx="2926080" cy="822960"/>
+          </a:xfrm>
+          <a:prstGeom prst="roundRect">
+            <a:avLst>
+              <a:gd name="adj" fmla="val 6667"/>
+            </a:avLst>
+          </a:prstGeom>
+          <a:solidFill>
+            <a:srgbClr val="FFFFFF"/>
+          </a:solidFill>
+          <a:ln/>
+          <a:effectLst>
+            <a:outerShdw sx="100000" sy="100000" kx="0" ky="0" algn="bl" rotWithShape="0" blurRad="127000" dist="25400" dir="5400000">
+              <a:srgbClr val="0B1220">
+                <a:alpha val="5000"/>
+              </a:srgbClr>
+            </a:outerShdw>
+          </a:effectLst>
+        </p:spPr>
+      </p:sp>
+      <p:sp>
+        <p:nvSpPr>
+          <p:cNvPr id="34" name="Text 32"/>
+          <p:cNvSpPr/>
+          <p:nvPr/>
+        </p:nvSpPr>
+        <p:spPr>
+          <a:xfrm>
+            <a:off x="8915400" y="4087368"/>
+            <a:ext cx="2606040" cy="411480"/>
+          </a:xfrm>
+          <a:prstGeom prst="rect">
+            <a:avLst/>
+          </a:prstGeom>
+          <a:noFill/>
+          <a:ln/>
+        </p:spPr>
+        <p:txBody>
+          <a:bodyPr wrap="square" lIns="0" tIns="0" rIns="0" bIns="0" rtlCol="0" anchor="ctr"/>
+          <a:lstStyle/>
+          <a:p>
+            <a:pPr indent="0" marL="0">
+              <a:buNone/>
+            </a:pPr>
+            <a:r>
+              <a:rPr lang="en-US" sz="1300" b="1" dirty="0">
+                <a:solidFill>
+                  <a:srgbClr val="0B1220"/>
+                </a:solidFill>
+                <a:latin typeface="Calibri" pitchFamily="34" charset="0"/>
+                <a:ea typeface="Calibri" pitchFamily="34" charset="-122"/>
+                <a:cs typeface="Calibri" pitchFamily="34" charset="-120"/>
+              </a:rPr>
+              <a:t>Observability</a:t>
+            </a:r>
+            <a:endParaRPr lang="en-US" sz="1300" dirty="0"/>
+          </a:p>
+        </p:txBody>
+      </p:sp>
+      <p:sp>
+        <p:nvSpPr>
+          <p:cNvPr id="35" name="Text 33"/>
+          <p:cNvSpPr/>
+          <p:nvPr/>
+        </p:nvSpPr>
+        <p:spPr>
+          <a:xfrm>
+            <a:off x="8915400" y="4453128"/>
+            <a:ext cx="2606040" cy="256032"/>
+          </a:xfrm>
+          <a:prstGeom prst="rect">
+            <a:avLst/>
+          </a:prstGeom>
+          <a:noFill/>
+          <a:ln/>
+        </p:spPr>
+        <p:txBody>
+          <a:bodyPr wrap="square" lIns="0" tIns="0" rIns="0" bIns="0" rtlCol="0" anchor="ctr"/>
+          <a:lstStyle/>
+          <a:p>
+            <a:pPr indent="0" marL="0">
+              <a:buNone/>
+            </a:pPr>
+            <a:r>
+              <a:rPr lang="en-US" sz="1100" dirty="0">
+                <a:solidFill>
+                  <a:srgbClr val="64748B"/>
+                </a:solidFill>
+                <a:latin typeface="Calibri" pitchFamily="34" charset="0"/>
+                <a:ea typeface="Calibri" pitchFamily="34" charset="-122"/>
+                <a:cs typeface="Calibri" pitchFamily="34" charset="-120"/>
+              </a:rPr>
+              <a:t>logs · metrics · traces</a:t>
+            </a:r>
+            <a:endParaRPr lang="en-US" sz="1100" dirty="0"/>
+          </a:p>
+        </p:txBody>
+      </p:sp>
+      <p:sp>
+        <p:nvSpPr>
+          <p:cNvPr id="36" name="Shape 34"/>
+          <p:cNvSpPr/>
+          <p:nvPr/>
+        </p:nvSpPr>
+        <p:spPr>
+          <a:xfrm>
+            <a:off x="8732520" y="4937760"/>
+            <a:ext cx="2926080" cy="822960"/>
+          </a:xfrm>
+          <a:prstGeom prst="roundRect">
+            <a:avLst>
+              <a:gd name="adj" fmla="val 6667"/>
+            </a:avLst>
+          </a:prstGeom>
+          <a:solidFill>
+            <a:srgbClr val="FFFFFF"/>
+          </a:solidFill>
+          <a:ln/>
+          <a:effectLst>
+            <a:outerShdw sx="100000" sy="100000" kx="0" ky="0" algn="bl" rotWithShape="0" blurRad="127000" dist="25400" dir="5400000">
+              <a:srgbClr val="0B1220">
+                <a:alpha val="5000"/>
+              </a:srgbClr>
+            </a:outerShdw>
+          </a:effectLst>
+        </p:spPr>
+      </p:sp>
+      <p:sp>
+        <p:nvSpPr>
+          <p:cNvPr id="37" name="Text 35"/>
+          <p:cNvSpPr/>
+          <p:nvPr/>
+        </p:nvSpPr>
+        <p:spPr>
+          <a:xfrm>
+            <a:off x="8915400" y="5047488"/>
+            <a:ext cx="2606040" cy="411480"/>
+          </a:xfrm>
+          <a:prstGeom prst="rect">
+            <a:avLst/>
+          </a:prstGeom>
+          <a:noFill/>
+          <a:ln/>
+        </p:spPr>
+        <p:txBody>
+          <a:bodyPr wrap="square" lIns="0" tIns="0" rIns="0" bIns="0" rtlCol="0" anchor="ctr"/>
+          <a:lstStyle/>
+          <a:p>
+            <a:pPr indent="0" marL="0">
+              <a:buNone/>
+            </a:pPr>
+            <a:r>
+              <a:rPr lang="en-US" sz="1300" b="1" dirty="0">
+                <a:solidFill>
+                  <a:srgbClr val="0B1220"/>
+                </a:solidFill>
+                <a:latin typeface="Calibri" pitchFamily="34" charset="0"/>
+                <a:ea typeface="Calibri" pitchFamily="34" charset="-122"/>
+                <a:cs typeface="Calibri" pitchFamily="34" charset="-120"/>
+              </a:rPr>
+              <a:t>Data store</a:t>
+            </a:r>
+            <a:endParaRPr lang="en-US" sz="1300" dirty="0"/>
+          </a:p>
+        </p:txBody>
+      </p:sp>
+      <p:sp>
+        <p:nvSpPr>
+          <p:cNvPr id="38" name="Text 36"/>
+          <p:cNvSpPr/>
+          <p:nvPr/>
+        </p:nvSpPr>
+        <p:spPr>
+          <a:xfrm>
+            <a:off x="8915400" y="5413248"/>
+            <a:ext cx="2606040" cy="256032"/>
+          </a:xfrm>
+          <a:prstGeom prst="rect">
+            <a:avLst/>
+          </a:prstGeom>
+          <a:noFill/>
+          <a:ln/>
+        </p:spPr>
+        <p:txBody>
+          <a:bodyPr wrap="square" lIns="0" tIns="0" rIns="0" bIns="0" rtlCol="0" anchor="ctr"/>
+          <a:lstStyle/>
+          <a:p>
+            <a:pPr indent="0" marL="0">
+              <a:buNone/>
+            </a:pPr>
+            <a:r>
+              <a:rPr lang="en-US" sz="1100" dirty="0">
+                <a:solidFill>
+                  <a:srgbClr val="64748B"/>
+                </a:solidFill>
+                <a:latin typeface="Calibri" pitchFamily="34" charset="0"/>
+                <a:ea typeface="Calibri" pitchFamily="34" charset="-122"/>
+                <a:cs typeface="Calibri" pitchFamily="34" charset="-120"/>
+              </a:rPr>
+              <a:t>PostgreSQL (owned)</a:t>
+            </a:r>
+            <a:endParaRPr lang="en-US" sz="1100" dirty="0"/>
+          </a:p>
+        </p:txBody>
+      </p:sp>
+      <p:sp>
+        <p:nvSpPr>
+          <p:cNvPr id="39" name="Text 37"/>
+          <p:cNvSpPr/>
+          <p:nvPr/>
+        </p:nvSpPr>
+        <p:spPr>
+          <a:xfrm>
+            <a:off x="3383280" y="3566160"/>
+            <a:ext cx="502920" cy="822960"/>
+          </a:xfrm>
+          <a:prstGeom prst="rect">
+            <a:avLst/>
+          </a:prstGeom>
+          <a:noFill/>
+          <a:ln/>
+        </p:spPr>
+        <p:txBody>
+          <a:bodyPr wrap="square" lIns="0" tIns="0" rIns="0" bIns="0" rtlCol="0" anchor="ctr"/>
+          <a:lstStyle/>
+          <a:p>
+            <a:pPr algn="ctr" indent="0" marL="0">
+              <a:buNone/>
+            </a:pPr>
+            <a:r>
+              <a:rPr lang="en-US" sz="900" dirty="0">
+                <a:solidFill>
+                  <a:srgbClr val="0F766E"/>
+                </a:solidFill>
+                <a:latin typeface="Calibri" pitchFamily="34" charset="0"/>
+                <a:ea typeface="Calibri" pitchFamily="34" charset="-122"/>
+                <a:cs typeface="Calibri" pitchFamily="34" charset="-120"/>
+              </a:rPr>
+              <a:t>sync HTTP</a:t>
+            </a:r>
+            <a:endParaRPr lang="en-US" sz="900" dirty="0"/>
+          </a:p>
+          <a:p>
+            <a:pPr algn="ctr" indent="0" marL="0">
+              <a:buNone/>
+            </a:pPr>
+            <a:r>
+              <a:rPr lang="en-US" sz="900" dirty="0">
+                <a:solidFill>
+                  <a:srgbClr val="0F766E"/>
+                </a:solidFill>
+                <a:latin typeface="Calibri" pitchFamily="34" charset="0"/>
+                <a:ea typeface="Calibri" pitchFamily="34" charset="-122"/>
+                <a:cs typeface="Calibri" pitchFamily="34" charset="-120"/>
+              </a:rPr>
+              <a:t>events / CRUD</a:t>
+            </a:r>
+            <a:endParaRPr lang="en-US" sz="900" dirty="0"/>
+          </a:p>
+        </p:txBody>
+      </p:sp>
+      <p:sp>
+        <p:nvSpPr>
+          <p:cNvPr id="40" name="Text 38"/>
           <p:cNvSpPr/>
           <p:nvPr/>
         </p:nvSpPr>
@@ -4330,7 +5202,7 @@
       </p:sp>
       <p:sp>
         <p:nvSpPr>
-          <p:cNvPr id="24" name="Text 22"/>
+          <p:cNvPr id="41" name="Text 39"/>
           <p:cNvSpPr/>
           <p:nvPr/>
         </p:nvSpPr>
@@ -4407,6 +5279,1692 @@
             <a:avLst/>
           </a:prstGeom>
           <a:solidFill>
+            <a:srgbClr val="F4F7FA"/>
+          </a:solidFill>
+          <a:ln/>
+        </p:spPr>
+      </p:sp>
+      <p:sp>
+        <p:nvSpPr>
+          <p:cNvPr id="3" name="Text 1"/>
+          <p:cNvSpPr/>
+          <p:nvPr/>
+        </p:nvSpPr>
+        <p:spPr>
+          <a:xfrm>
+            <a:off x="502920" y="347472"/>
+            <a:ext cx="11155680" cy="457200"/>
+          </a:xfrm>
+          <a:prstGeom prst="rect">
+            <a:avLst/>
+          </a:prstGeom>
+          <a:noFill/>
+          <a:ln/>
+        </p:spPr>
+        <p:txBody>
+          <a:bodyPr wrap="square" lIns="0" tIns="0" rIns="0" bIns="0" rtlCol="0" anchor="ctr"/>
+          <a:lstStyle/>
+          <a:p>
+            <a:pPr indent="0" marL="0">
+              <a:buNone/>
+            </a:pPr>
+            <a:r>
+              <a:rPr lang="en-US" sz="2800" b="1" dirty="0">
+                <a:solidFill>
+                  <a:srgbClr val="0B1220"/>
+                </a:solidFill>
+                <a:latin typeface="Calibri" pitchFamily="34" charset="0"/>
+                <a:ea typeface="Calibri" pitchFamily="34" charset="-122"/>
+                <a:cs typeface="Calibri" pitchFamily="34" charset="-120"/>
+              </a:rPr>
+              <a:t>Microservices design principles</a:t>
+            </a:r>
+            <a:endParaRPr lang="en-US" sz="2800" dirty="0"/>
+          </a:p>
+        </p:txBody>
+      </p:sp>
+      <p:sp>
+        <p:nvSpPr>
+          <p:cNvPr id="4" name="Text 2"/>
+          <p:cNvSpPr/>
+          <p:nvPr/>
+        </p:nvSpPr>
+        <p:spPr>
+          <a:xfrm>
+            <a:off x="502920" y="841248"/>
+            <a:ext cx="11155680" cy="292608"/>
+          </a:xfrm>
+          <a:prstGeom prst="rect">
+            <a:avLst/>
+          </a:prstGeom>
+          <a:noFill/>
+          <a:ln/>
+        </p:spPr>
+        <p:txBody>
+          <a:bodyPr wrap="square" lIns="0" tIns="0" rIns="0" bIns="0" rtlCol="0" anchor="ctr"/>
+          <a:lstStyle/>
+          <a:p>
+            <a:pPr indent="0" marL="0">
+              <a:buNone/>
+            </a:pPr>
+            <a:r>
+              <a:rPr lang="en-US" sz="1400" dirty="0">
+                <a:solidFill>
+                  <a:srgbClr val="64748B"/>
+                </a:solidFill>
+                <a:latin typeface="Calibri" pitchFamily="34" charset="0"/>
+                <a:ea typeface="Calibri" pitchFamily="34" charset="-122"/>
+                <a:cs typeface="Calibri" pitchFamily="34" charset="-120"/>
+              </a:rPr>
+              <a:t>How LedgeRX fits a service-oriented platform</a:t>
+            </a:r>
+            <a:endParaRPr lang="en-US" sz="1400" dirty="0"/>
+          </a:p>
+        </p:txBody>
+      </p:sp>
+      <p:sp>
+        <p:nvSpPr>
+          <p:cNvPr id="5" name="Shape 3"/>
+          <p:cNvSpPr/>
+          <p:nvPr/>
+        </p:nvSpPr>
+        <p:spPr>
+          <a:xfrm>
+            <a:off x="502920" y="1325880"/>
+            <a:ext cx="3611880" cy="2103120"/>
+          </a:xfrm>
+          <a:prstGeom prst="roundRect">
+            <a:avLst>
+              <a:gd name="adj" fmla="val 2609"/>
+            </a:avLst>
+          </a:prstGeom>
+          <a:solidFill>
+            <a:srgbClr val="FFFFFF"/>
+          </a:solidFill>
+          <a:ln/>
+          <a:effectLst>
+            <a:outerShdw sx="100000" sy="100000" kx="0" ky="0" algn="bl" rotWithShape="0" blurRad="127000" dist="25400" dir="5400000">
+              <a:srgbClr val="0B1220">
+                <a:alpha val="5000"/>
+              </a:srgbClr>
+            </a:outerShdw>
+          </a:effectLst>
+        </p:spPr>
+      </p:sp>
+      <p:sp>
+        <p:nvSpPr>
+          <p:cNvPr id="6" name="Text 4"/>
+          <p:cNvSpPr/>
+          <p:nvPr/>
+        </p:nvSpPr>
+        <p:spPr>
+          <a:xfrm>
+            <a:off x="777240" y="1645920"/>
+            <a:ext cx="3063240" cy="411480"/>
+          </a:xfrm>
+          <a:prstGeom prst="rect">
+            <a:avLst/>
+          </a:prstGeom>
+          <a:noFill/>
+          <a:ln/>
+        </p:spPr>
+        <p:txBody>
+          <a:bodyPr wrap="square" lIns="0" tIns="0" rIns="0" bIns="0" rtlCol="0" anchor="ctr"/>
+          <a:lstStyle/>
+          <a:p>
+            <a:pPr indent="0" marL="0">
+              <a:buNone/>
+            </a:pPr>
+            <a:r>
+              <a:rPr lang="en-US" sz="1600" b="1" dirty="0">
+                <a:solidFill>
+                  <a:srgbClr val="0C2340"/>
+                </a:solidFill>
+                <a:latin typeface="Calibri" pitchFamily="34" charset="0"/>
+                <a:ea typeface="Calibri" pitchFamily="34" charset="-122"/>
+                <a:cs typeface="Calibri" pitchFamily="34" charset="-120"/>
+              </a:rPr>
+              <a:t>Bounded context</a:t>
+            </a:r>
+            <a:endParaRPr lang="en-US" sz="1600" dirty="0"/>
+          </a:p>
+        </p:txBody>
+      </p:sp>
+      <p:sp>
+        <p:nvSpPr>
+          <p:cNvPr id="7" name="Text 5"/>
+          <p:cNvSpPr/>
+          <p:nvPr/>
+        </p:nvSpPr>
+        <p:spPr>
+          <a:xfrm>
+            <a:off x="777240" y="2194560"/>
+            <a:ext cx="3063240" cy="960120"/>
+          </a:xfrm>
+          <a:prstGeom prst="rect">
+            <a:avLst/>
+          </a:prstGeom>
+          <a:noFill/>
+          <a:ln/>
+        </p:spPr>
+        <p:txBody>
+          <a:bodyPr wrap="square" lIns="0" tIns="0" rIns="0" bIns="0" rtlCol="0" anchor="ctr"/>
+          <a:lstStyle/>
+          <a:p>
+            <a:pPr indent="0" marL="0">
+              <a:buNone/>
+            </a:pPr>
+            <a:r>
+              <a:rPr lang="en-US" sz="1300" dirty="0">
+                <a:solidFill>
+                  <a:srgbClr val="334155"/>
+                </a:solidFill>
+                <a:latin typeface="Calibri" pitchFamily="34" charset="0"/>
+                <a:ea typeface="Calibri" pitchFamily="34" charset="-122"/>
+                <a:cs typeface="Calibri" pitchFamily="34" charset="-120"/>
+              </a:rPr>
+              <a:t>Ledger/loyalty only. No CRM fields, no payment capture, no campaign content.</a:t>
+            </a:r>
+            <a:endParaRPr lang="en-US" sz="1300" dirty="0"/>
+          </a:p>
+        </p:txBody>
+      </p:sp>
+      <p:sp>
+        <p:nvSpPr>
+          <p:cNvPr id="8" name="Shape 6"/>
+          <p:cNvSpPr/>
+          <p:nvPr/>
+        </p:nvSpPr>
+        <p:spPr>
+          <a:xfrm>
+            <a:off x="4343400" y="1325880"/>
+            <a:ext cx="3611880" cy="2103120"/>
+          </a:xfrm>
+          <a:prstGeom prst="roundRect">
+            <a:avLst>
+              <a:gd name="adj" fmla="val 2609"/>
+            </a:avLst>
+          </a:prstGeom>
+          <a:solidFill>
+            <a:srgbClr val="FFFFFF"/>
+          </a:solidFill>
+          <a:ln/>
+          <a:effectLst>
+            <a:outerShdw sx="100000" sy="100000" kx="0" ky="0" algn="bl" rotWithShape="0" blurRad="127000" dist="25400" dir="5400000">
+              <a:srgbClr val="0B1220">
+                <a:alpha val="5000"/>
+              </a:srgbClr>
+            </a:outerShdw>
+          </a:effectLst>
+        </p:spPr>
+      </p:sp>
+      <p:sp>
+        <p:nvSpPr>
+          <p:cNvPr id="9" name="Text 7"/>
+          <p:cNvSpPr/>
+          <p:nvPr/>
+        </p:nvSpPr>
+        <p:spPr>
+          <a:xfrm>
+            <a:off x="4617720" y="1645920"/>
+            <a:ext cx="3063240" cy="411480"/>
+          </a:xfrm>
+          <a:prstGeom prst="rect">
+            <a:avLst/>
+          </a:prstGeom>
+          <a:noFill/>
+          <a:ln/>
+        </p:spPr>
+        <p:txBody>
+          <a:bodyPr wrap="square" lIns="0" tIns="0" rIns="0" bIns="0" rtlCol="0" anchor="ctr"/>
+          <a:lstStyle/>
+          <a:p>
+            <a:pPr indent="0" marL="0">
+              <a:buNone/>
+            </a:pPr>
+            <a:r>
+              <a:rPr lang="en-US" sz="1600" b="1" dirty="0">
+                <a:solidFill>
+                  <a:srgbClr val="0C2340"/>
+                </a:solidFill>
+                <a:latin typeface="Calibri" pitchFamily="34" charset="0"/>
+                <a:ea typeface="Calibri" pitchFamily="34" charset="-122"/>
+                <a:cs typeface="Calibri" pitchFamily="34" charset="-120"/>
+              </a:rPr>
+              <a:t>Own data store</a:t>
+            </a:r>
+            <a:endParaRPr lang="en-US" sz="1600" dirty="0"/>
+          </a:p>
+        </p:txBody>
+      </p:sp>
+      <p:sp>
+        <p:nvSpPr>
+          <p:cNvPr id="10" name="Text 8"/>
+          <p:cNvSpPr/>
+          <p:nvPr/>
+        </p:nvSpPr>
+        <p:spPr>
+          <a:xfrm>
+            <a:off x="4617720" y="2194560"/>
+            <a:ext cx="3063240" cy="960120"/>
+          </a:xfrm>
+          <a:prstGeom prst="rect">
+            <a:avLst/>
+          </a:prstGeom>
+          <a:noFill/>
+          <a:ln/>
+        </p:spPr>
+        <p:txBody>
+          <a:bodyPr wrap="square" lIns="0" tIns="0" rIns="0" bIns="0" rtlCol="0" anchor="ctr"/>
+          <a:lstStyle/>
+          <a:p>
+            <a:pPr indent="0" marL="0">
+              <a:buNone/>
+            </a:pPr>
+            <a:r>
+              <a:rPr lang="en-US" sz="1300" dirty="0">
+                <a:solidFill>
+                  <a:srgbClr val="334155"/>
+                </a:solidFill>
+                <a:latin typeface="Calibri" pitchFamily="34" charset="0"/>
+                <a:ea typeface="Calibri" pitchFamily="34" charset="-122"/>
+                <a:cs typeface="Calibri" pitchFamily="34" charset="-120"/>
+              </a:rPr>
+              <a:t>Dedicated PostgreSQL. Other services never write LedgeRX tables directly.</a:t>
+            </a:r>
+            <a:endParaRPr lang="en-US" sz="1300" dirty="0"/>
+          </a:p>
+        </p:txBody>
+      </p:sp>
+      <p:sp>
+        <p:nvSpPr>
+          <p:cNvPr id="11" name="Shape 9"/>
+          <p:cNvSpPr/>
+          <p:nvPr/>
+        </p:nvSpPr>
+        <p:spPr>
+          <a:xfrm>
+            <a:off x="8183880" y="1325880"/>
+            <a:ext cx="3611880" cy="2103120"/>
+          </a:xfrm>
+          <a:prstGeom prst="roundRect">
+            <a:avLst>
+              <a:gd name="adj" fmla="val 2609"/>
+            </a:avLst>
+          </a:prstGeom>
+          <a:solidFill>
+            <a:srgbClr val="FFFFFF"/>
+          </a:solidFill>
+          <a:ln/>
+          <a:effectLst>
+            <a:outerShdw sx="100000" sy="100000" kx="0" ky="0" algn="bl" rotWithShape="0" blurRad="127000" dist="25400" dir="5400000">
+              <a:srgbClr val="0B1220">
+                <a:alpha val="5000"/>
+              </a:srgbClr>
+            </a:outerShdw>
+          </a:effectLst>
+        </p:spPr>
+      </p:sp>
+      <p:sp>
+        <p:nvSpPr>
+          <p:cNvPr id="12" name="Text 10"/>
+          <p:cNvSpPr/>
+          <p:nvPr/>
+        </p:nvSpPr>
+        <p:spPr>
+          <a:xfrm>
+            <a:off x="8458200" y="1645920"/>
+            <a:ext cx="3063240" cy="411480"/>
+          </a:xfrm>
+          <a:prstGeom prst="rect">
+            <a:avLst/>
+          </a:prstGeom>
+          <a:noFill/>
+          <a:ln/>
+        </p:spPr>
+        <p:txBody>
+          <a:bodyPr wrap="square" lIns="0" tIns="0" rIns="0" bIns="0" rtlCol="0" anchor="ctr"/>
+          <a:lstStyle/>
+          <a:p>
+            <a:pPr indent="0" marL="0">
+              <a:buNone/>
+            </a:pPr>
+            <a:r>
+              <a:rPr lang="en-US" sz="1600" b="1" dirty="0">
+                <a:solidFill>
+                  <a:srgbClr val="0C2340"/>
+                </a:solidFill>
+                <a:latin typeface="Calibri" pitchFamily="34" charset="0"/>
+                <a:ea typeface="Calibri" pitchFamily="34" charset="-122"/>
+                <a:cs typeface="Calibri" pitchFamily="34" charset="-120"/>
+              </a:rPr>
+              <a:t>API as contract</a:t>
+            </a:r>
+            <a:endParaRPr lang="en-US" sz="1600" dirty="0"/>
+          </a:p>
+        </p:txBody>
+      </p:sp>
+      <p:sp>
+        <p:nvSpPr>
+          <p:cNvPr id="13" name="Text 11"/>
+          <p:cNvSpPr/>
+          <p:nvPr/>
+        </p:nvSpPr>
+        <p:spPr>
+          <a:xfrm>
+            <a:off x="8458200" y="2194560"/>
+            <a:ext cx="3063240" cy="960120"/>
+          </a:xfrm>
+          <a:prstGeom prst="rect">
+            <a:avLst/>
+          </a:prstGeom>
+          <a:noFill/>
+          <a:ln/>
+        </p:spPr>
+        <p:txBody>
+          <a:bodyPr wrap="square" lIns="0" tIns="0" rIns="0" bIns="0" rtlCol="0" anchor="ctr"/>
+          <a:lstStyle/>
+          <a:p>
+            <a:pPr indent="0" marL="0">
+              <a:buNone/>
+            </a:pPr>
+            <a:r>
+              <a:rPr lang="en-US" sz="1300" dirty="0">
+                <a:solidFill>
+                  <a:srgbClr val="334155"/>
+                </a:solidFill>
+                <a:latin typeface="Calibri" pitchFamily="34" charset="0"/>
+                <a:ea typeface="Calibri" pitchFamily="34" charset="-122"/>
+                <a:cs typeface="Calibri" pitchFamily="34" charset="-120"/>
+              </a:rPr>
+              <a:t>Stable product paths: /wallets, /integrations/webhooks, /digestion-rules, /coa-profiles.</a:t>
+            </a:r>
+            <a:endParaRPr lang="en-US" sz="1300" dirty="0"/>
+          </a:p>
+        </p:txBody>
+      </p:sp>
+      <p:sp>
+        <p:nvSpPr>
+          <p:cNvPr id="14" name="Shape 12"/>
+          <p:cNvSpPr/>
+          <p:nvPr/>
+        </p:nvSpPr>
+        <p:spPr>
+          <a:xfrm>
+            <a:off x="502920" y="3657600"/>
+            <a:ext cx="3611880" cy="2103120"/>
+          </a:xfrm>
+          <a:prstGeom prst="roundRect">
+            <a:avLst>
+              <a:gd name="adj" fmla="val 2609"/>
+            </a:avLst>
+          </a:prstGeom>
+          <a:solidFill>
+            <a:srgbClr val="FFFFFF"/>
+          </a:solidFill>
+          <a:ln/>
+          <a:effectLst>
+            <a:outerShdw sx="100000" sy="100000" kx="0" ky="0" algn="bl" rotWithShape="0" blurRad="127000" dist="25400" dir="5400000">
+              <a:srgbClr val="0B1220">
+                <a:alpha val="5000"/>
+              </a:srgbClr>
+            </a:outerShdw>
+          </a:effectLst>
+        </p:spPr>
+      </p:sp>
+      <p:sp>
+        <p:nvSpPr>
+          <p:cNvPr id="15" name="Text 13"/>
+          <p:cNvSpPr/>
+          <p:nvPr/>
+        </p:nvSpPr>
+        <p:spPr>
+          <a:xfrm>
+            <a:off x="777240" y="3977640"/>
+            <a:ext cx="3063240" cy="411480"/>
+          </a:xfrm>
+          <a:prstGeom prst="rect">
+            <a:avLst/>
+          </a:prstGeom>
+          <a:noFill/>
+          <a:ln/>
+        </p:spPr>
+        <p:txBody>
+          <a:bodyPr wrap="square" lIns="0" tIns="0" rIns="0" bIns="0" rtlCol="0" anchor="ctr"/>
+          <a:lstStyle/>
+          <a:p>
+            <a:pPr indent="0" marL="0">
+              <a:buNone/>
+            </a:pPr>
+            <a:r>
+              <a:rPr lang="en-US" sz="1600" b="1" dirty="0">
+                <a:solidFill>
+                  <a:srgbClr val="0C2340"/>
+                </a:solidFill>
+                <a:latin typeface="Calibri" pitchFamily="34" charset="0"/>
+                <a:ea typeface="Calibri" pitchFamily="34" charset="-122"/>
+                <a:cs typeface="Calibri" pitchFamily="34" charset="-120"/>
+              </a:rPr>
+              <a:t>Independent deploy</a:t>
+            </a:r>
+            <a:endParaRPr lang="en-US" sz="1600" dirty="0"/>
+          </a:p>
+        </p:txBody>
+      </p:sp>
+      <p:sp>
+        <p:nvSpPr>
+          <p:cNvPr id="16" name="Text 14"/>
+          <p:cNvSpPr/>
+          <p:nvPr/>
+        </p:nvSpPr>
+        <p:spPr>
+          <a:xfrm>
+            <a:off x="777240" y="4526280"/>
+            <a:ext cx="3063240" cy="960120"/>
+          </a:xfrm>
+          <a:prstGeom prst="rect">
+            <a:avLst/>
+          </a:prstGeom>
+          <a:noFill/>
+          <a:ln/>
+        </p:spPr>
+        <p:txBody>
+          <a:bodyPr wrap="square" lIns="0" tIns="0" rIns="0" bIns="0" rtlCol="0" anchor="ctr"/>
+          <a:lstStyle/>
+          <a:p>
+            <a:pPr indent="0" marL="0">
+              <a:buNone/>
+            </a:pPr>
+            <a:r>
+              <a:rPr lang="en-US" sz="1300" dirty="0">
+                <a:solidFill>
+                  <a:srgbClr val="334155"/>
+                </a:solidFill>
+                <a:latin typeface="Calibri" pitchFamily="34" charset="0"/>
+                <a:ea typeface="Calibri" pitchFamily="34" charset="-122"/>
+                <a:cs typeface="Calibri" pitchFamily="34" charset="-120"/>
+              </a:rPr>
+              <a:t>Ship ledger-engine without releasing CRM or POS. Rules change without redeploy.</a:t>
+            </a:r>
+            <a:endParaRPr lang="en-US" sz="1300" dirty="0"/>
+          </a:p>
+        </p:txBody>
+      </p:sp>
+      <p:sp>
+        <p:nvSpPr>
+          <p:cNvPr id="17" name="Shape 15"/>
+          <p:cNvSpPr/>
+          <p:nvPr/>
+        </p:nvSpPr>
+        <p:spPr>
+          <a:xfrm>
+            <a:off x="4343400" y="3657600"/>
+            <a:ext cx="3611880" cy="2103120"/>
+          </a:xfrm>
+          <a:prstGeom prst="roundRect">
+            <a:avLst>
+              <a:gd name="adj" fmla="val 2609"/>
+            </a:avLst>
+          </a:prstGeom>
+          <a:solidFill>
+            <a:srgbClr val="FFFFFF"/>
+          </a:solidFill>
+          <a:ln/>
+          <a:effectLst>
+            <a:outerShdw sx="100000" sy="100000" kx="0" ky="0" algn="bl" rotWithShape="0" blurRad="127000" dist="25400" dir="5400000">
+              <a:srgbClr val="0B1220">
+                <a:alpha val="5000"/>
+              </a:srgbClr>
+            </a:outerShdw>
+          </a:effectLst>
+        </p:spPr>
+      </p:sp>
+      <p:sp>
+        <p:nvSpPr>
+          <p:cNvPr id="18" name="Text 16"/>
+          <p:cNvSpPr/>
+          <p:nvPr/>
+        </p:nvSpPr>
+        <p:spPr>
+          <a:xfrm>
+            <a:off x="4617720" y="3977640"/>
+            <a:ext cx="3063240" cy="411480"/>
+          </a:xfrm>
+          <a:prstGeom prst="rect">
+            <a:avLst/>
+          </a:prstGeom>
+          <a:noFill/>
+          <a:ln/>
+        </p:spPr>
+        <p:txBody>
+          <a:bodyPr wrap="square" lIns="0" tIns="0" rIns="0" bIns="0" rtlCol="0" anchor="ctr"/>
+          <a:lstStyle/>
+          <a:p>
+            <a:pPr indent="0" marL="0">
+              <a:buNone/>
+            </a:pPr>
+            <a:r>
+              <a:rPr lang="en-US" sz="1600" b="1" dirty="0">
+                <a:solidFill>
+                  <a:srgbClr val="0C2340"/>
+                </a:solidFill>
+                <a:latin typeface="Calibri" pitchFamily="34" charset="0"/>
+                <a:ea typeface="Calibri" pitchFamily="34" charset="-122"/>
+                <a:cs typeface="Calibri" pitchFamily="34" charset="-120"/>
+              </a:rPr>
+              <a:t>Async-ready edge</a:t>
+            </a:r>
+            <a:endParaRPr lang="en-US" sz="1600" dirty="0"/>
+          </a:p>
+        </p:txBody>
+      </p:sp>
+      <p:sp>
+        <p:nvSpPr>
+          <p:cNvPr id="19" name="Text 17"/>
+          <p:cNvSpPr/>
+          <p:nvPr/>
+        </p:nvSpPr>
+        <p:spPr>
+          <a:xfrm>
+            <a:off x="4617720" y="4526280"/>
+            <a:ext cx="3063240" cy="960120"/>
+          </a:xfrm>
+          <a:prstGeom prst="rect">
+            <a:avLst/>
+          </a:prstGeom>
+          <a:noFill/>
+          <a:ln/>
+        </p:spPr>
+        <p:txBody>
+          <a:bodyPr wrap="square" lIns="0" tIns="0" rIns="0" bIns="0" rtlCol="0" anchor="ctr"/>
+          <a:lstStyle/>
+          <a:p>
+            <a:pPr indent="0" marL="0">
+              <a:buNone/>
+            </a:pPr>
+            <a:r>
+              <a:rPr lang="en-US" sz="1300" dirty="0">
+                <a:solidFill>
+                  <a:srgbClr val="334155"/>
+                </a:solidFill>
+                <a:latin typeface="Calibri" pitchFamily="34" charset="0"/>
+                <a:ea typeface="Calibri" pitchFamily="34" charset="-122"/>
+                <a:cs typeface="Calibri" pitchFamily="34" charset="-120"/>
+              </a:rPr>
+              <a:t>Today: sync HTTP webhooks. Same contract can sit behind a queue consumer later.</a:t>
+            </a:r>
+            <a:endParaRPr lang="en-US" sz="1300" dirty="0"/>
+          </a:p>
+        </p:txBody>
+      </p:sp>
+      <p:sp>
+        <p:nvSpPr>
+          <p:cNvPr id="20" name="Shape 18"/>
+          <p:cNvSpPr/>
+          <p:nvPr/>
+        </p:nvSpPr>
+        <p:spPr>
+          <a:xfrm>
+            <a:off x="8183880" y="3657600"/>
+            <a:ext cx="3611880" cy="2103120"/>
+          </a:xfrm>
+          <a:prstGeom prst="roundRect">
+            <a:avLst>
+              <a:gd name="adj" fmla="val 2609"/>
+            </a:avLst>
+          </a:prstGeom>
+          <a:solidFill>
+            <a:srgbClr val="FFFFFF"/>
+          </a:solidFill>
+          <a:ln/>
+          <a:effectLst>
+            <a:outerShdw sx="100000" sy="100000" kx="0" ky="0" algn="bl" rotWithShape="0" blurRad="127000" dist="25400" dir="5400000">
+              <a:srgbClr val="0B1220">
+                <a:alpha val="5000"/>
+              </a:srgbClr>
+            </a:outerShdw>
+          </a:effectLst>
+        </p:spPr>
+      </p:sp>
+      <p:sp>
+        <p:nvSpPr>
+          <p:cNvPr id="21" name="Text 19"/>
+          <p:cNvSpPr/>
+          <p:nvPr/>
+        </p:nvSpPr>
+        <p:spPr>
+          <a:xfrm>
+            <a:off x="8458200" y="3977640"/>
+            <a:ext cx="3063240" cy="411480"/>
+          </a:xfrm>
+          <a:prstGeom prst="rect">
+            <a:avLst/>
+          </a:prstGeom>
+          <a:noFill/>
+          <a:ln/>
+        </p:spPr>
+        <p:txBody>
+          <a:bodyPr wrap="square" lIns="0" tIns="0" rIns="0" bIns="0" rtlCol="0" anchor="ctr"/>
+          <a:lstStyle/>
+          <a:p>
+            <a:pPr indent="0" marL="0">
+              <a:buNone/>
+            </a:pPr>
+            <a:r>
+              <a:rPr lang="en-US" sz="1600" b="1" dirty="0">
+                <a:solidFill>
+                  <a:srgbClr val="0C2340"/>
+                </a:solidFill>
+                <a:latin typeface="Calibri" pitchFamily="34" charset="0"/>
+                <a:ea typeface="Calibri" pitchFamily="34" charset="-122"/>
+                <a:cs typeface="Calibri" pitchFamily="34" charset="-120"/>
+              </a:rPr>
+              <a:t>Internal network</a:t>
+            </a:r>
+            <a:endParaRPr lang="en-US" sz="1600" dirty="0"/>
+          </a:p>
+        </p:txBody>
+      </p:sp>
+      <p:sp>
+        <p:nvSpPr>
+          <p:cNvPr id="22" name="Text 20"/>
+          <p:cNvSpPr/>
+          <p:nvPr/>
+        </p:nvSpPr>
+        <p:spPr>
+          <a:xfrm>
+            <a:off x="8458200" y="4526280"/>
+            <a:ext cx="3063240" cy="960120"/>
+          </a:xfrm>
+          <a:prstGeom prst="rect">
+            <a:avLst/>
+          </a:prstGeom>
+          <a:noFill/>
+          <a:ln/>
+        </p:spPr>
+        <p:txBody>
+          <a:bodyPr wrap="square" lIns="0" tIns="0" rIns="0" bIns="0" rtlCol="0" anchor="ctr"/>
+          <a:lstStyle/>
+          <a:p>
+            <a:pPr indent="0" marL="0">
+              <a:buNone/>
+            </a:pPr>
+            <a:r>
+              <a:rPr lang="en-US" sz="1300" dirty="0">
+                <a:solidFill>
+                  <a:srgbClr val="334155"/>
+                </a:solidFill>
+                <a:latin typeface="Calibri" pitchFamily="34" charset="0"/>
+                <a:ea typeface="Calibri" pitchFamily="34" charset="-122"/>
+                <a:cs typeface="Calibri" pitchFamily="34" charset="-120"/>
+              </a:rPr>
+              <a:t>ClusterIP / mesh only. Cross-service auth (API key) is planned debt, not a public OAuth product.</a:t>
+            </a:r>
+            <a:endParaRPr lang="en-US" sz="1300" dirty="0"/>
+          </a:p>
+        </p:txBody>
+      </p:sp>
+      <p:sp>
+        <p:nvSpPr>
+          <p:cNvPr id="23" name="Text 21"/>
+          <p:cNvSpPr/>
+          <p:nvPr/>
+        </p:nvSpPr>
+        <p:spPr>
+          <a:xfrm>
+            <a:off x="502920" y="6510528"/>
+            <a:ext cx="8229600" cy="201168"/>
+          </a:xfrm>
+          <a:prstGeom prst="rect">
+            <a:avLst/>
+          </a:prstGeom>
+          <a:noFill/>
+          <a:ln/>
+        </p:spPr>
+        <p:txBody>
+          <a:bodyPr wrap="square" lIns="0" tIns="0" rIns="0" bIns="0" rtlCol="0" anchor="ctr"/>
+          <a:lstStyle/>
+          <a:p>
+            <a:pPr indent="0" marL="0">
+              <a:buNone/>
+            </a:pPr>
+            <a:r>
+              <a:rPr lang="en-US" sz="1000" dirty="0">
+                <a:solidFill>
+                  <a:srgbClr val="64748B"/>
+                </a:solidFill>
+                <a:latin typeface="Calibri" pitchFamily="34" charset="0"/>
+                <a:ea typeface="Calibri" pitchFamily="34" charset="-122"/>
+                <a:cs typeface="Calibri" pitchFamily="34" charset="-120"/>
+              </a:rPr>
+              <a:t>LedgeRX  |  Executive briefing</a:t>
+            </a:r>
+            <a:endParaRPr lang="en-US" sz="1000" dirty="0"/>
+          </a:p>
+        </p:txBody>
+      </p:sp>
+      <p:sp>
+        <p:nvSpPr>
+          <p:cNvPr id="24" name="Text 22"/>
+          <p:cNvSpPr/>
+          <p:nvPr/>
+        </p:nvSpPr>
+        <p:spPr>
+          <a:xfrm>
+            <a:off x="11155680" y="6510528"/>
+            <a:ext cx="548640" cy="201168"/>
+          </a:xfrm>
+          <a:prstGeom prst="rect">
+            <a:avLst/>
+          </a:prstGeom>
+          <a:noFill/>
+          <a:ln/>
+        </p:spPr>
+        <p:txBody>
+          <a:bodyPr wrap="square" lIns="0" tIns="0" rIns="0" bIns="0" rtlCol="0" anchor="ctr"/>
+          <a:lstStyle/>
+          <a:p>
+            <a:pPr algn="r" indent="0" marL="0">
+              <a:buNone/>
+            </a:pPr>
+            <a:r>
+              <a:rPr lang="en-US" sz="1000" dirty="0">
+                <a:solidFill>
+                  <a:srgbClr val="64748B"/>
+                </a:solidFill>
+                <a:latin typeface="Calibri" pitchFamily="34" charset="0"/>
+                <a:ea typeface="Calibri" pitchFamily="34" charset="-122"/>
+                <a:cs typeface="Calibri" pitchFamily="34" charset="-120"/>
+              </a:rPr>
+              <a:t>12</a:t>
+            </a:r>
+            <a:endParaRPr lang="en-US" sz="1000" dirty="0"/>
+          </a:p>
+        </p:txBody>
+      </p:sp>
+    </p:spTree>
+  </p:cSld>
+  <p:clrMapOvr>
+    <a:masterClrMapping/>
+  </p:clrMapOvr>
+</p:sld>
+</file>
+
+<file path=ppt/slides/slide13.xml><?xml version="1.0" encoding="utf-8"?>
+<p:sld xmlns:a="http://schemas.openxmlformats.org/drawingml/2006/main" xmlns:r="http://schemas.openxmlformats.org/officeDocument/2006/relationships" xmlns:p="http://schemas.openxmlformats.org/presentationml/2006/main">
+  <p:cSld name="Slide 13">
+    <p:spTree>
+      <p:nvGrpSpPr>
+        <p:cNvPr id="1" name=""/>
+        <p:cNvGrpSpPr/>
+        <p:nvPr/>
+      </p:nvGrpSpPr>
+      <p:grpSpPr>
+        <a:xfrm>
+          <a:off x="0" y="0"/>
+          <a:ext cx="0" cy="0"/>
+          <a:chOff x="0" y="0"/>
+          <a:chExt cx="0" cy="0"/>
+        </a:xfrm>
+      </p:grpSpPr>
+      <p:sp>
+        <p:nvSpPr>
+          <p:cNvPr id="2" name="Shape 0"/>
+          <p:cNvSpPr/>
+          <p:nvPr/>
+        </p:nvSpPr>
+        <p:spPr>
+          <a:xfrm>
+            <a:off x="0" y="0"/>
+            <a:ext cx="12161520" cy="6858000"/>
+          </a:xfrm>
+          <a:prstGeom prst="rect">
+            <a:avLst/>
+          </a:prstGeom>
+          <a:solidFill>
+            <a:srgbClr val="F4F7FA"/>
+          </a:solidFill>
+          <a:ln/>
+        </p:spPr>
+      </p:sp>
+      <p:sp>
+        <p:nvSpPr>
+          <p:cNvPr id="3" name="Text 1"/>
+          <p:cNvSpPr/>
+          <p:nvPr/>
+        </p:nvSpPr>
+        <p:spPr>
+          <a:xfrm>
+            <a:off x="502920" y="347472"/>
+            <a:ext cx="11155680" cy="457200"/>
+          </a:xfrm>
+          <a:prstGeom prst="rect">
+            <a:avLst/>
+          </a:prstGeom>
+          <a:noFill/>
+          <a:ln/>
+        </p:spPr>
+        <p:txBody>
+          <a:bodyPr wrap="square" lIns="0" tIns="0" rIns="0" bIns="0" rtlCol="0" anchor="ctr"/>
+          <a:lstStyle/>
+          <a:p>
+            <a:pPr indent="0" marL="0">
+              <a:buNone/>
+            </a:pPr>
+            <a:r>
+              <a:rPr lang="en-US" sz="2800" b="1" dirty="0">
+                <a:solidFill>
+                  <a:srgbClr val="0B1220"/>
+                </a:solidFill>
+                <a:latin typeface="Calibri" pitchFamily="34" charset="0"/>
+                <a:ea typeface="Calibri" pitchFamily="34" charset="-122"/>
+                <a:cs typeface="Calibri" pitchFamily="34" charset="-120"/>
+              </a:rPr>
+              <a:t>Business outcomes</a:t>
+            </a:r>
+            <a:endParaRPr lang="en-US" sz="2800" dirty="0"/>
+          </a:p>
+        </p:txBody>
+      </p:sp>
+      <p:sp>
+        <p:nvSpPr>
+          <p:cNvPr id="4" name="Text 2"/>
+          <p:cNvSpPr/>
+          <p:nvPr/>
+        </p:nvSpPr>
+        <p:spPr>
+          <a:xfrm>
+            <a:off x="502920" y="841248"/>
+            <a:ext cx="11155680" cy="292608"/>
+          </a:xfrm>
+          <a:prstGeom prst="rect">
+            <a:avLst/>
+          </a:prstGeom>
+          <a:noFill/>
+          <a:ln/>
+        </p:spPr>
+        <p:txBody>
+          <a:bodyPr wrap="square" lIns="0" tIns="0" rIns="0" bIns="0" rtlCol="0" anchor="ctr"/>
+          <a:lstStyle/>
+          <a:p>
+            <a:pPr indent="0" marL="0">
+              <a:buNone/>
+            </a:pPr>
+            <a:r>
+              <a:rPr lang="en-US" sz="1400" dirty="0">
+                <a:solidFill>
+                  <a:srgbClr val="64748B"/>
+                </a:solidFill>
+                <a:latin typeface="Calibri" pitchFamily="34" charset="0"/>
+                <a:ea typeface="Calibri" pitchFamily="34" charset="-122"/>
+                <a:cs typeface="Calibri" pitchFamily="34" charset="-120"/>
+              </a:rPr>
+              <a:t>What leadership should expect</a:t>
+            </a:r>
+            <a:endParaRPr lang="en-US" sz="1400" dirty="0"/>
+          </a:p>
+        </p:txBody>
+      </p:sp>
+      <p:sp>
+        <p:nvSpPr>
+          <p:cNvPr id="5" name="Shape 3"/>
+          <p:cNvSpPr/>
+          <p:nvPr/>
+        </p:nvSpPr>
+        <p:spPr>
+          <a:xfrm>
+            <a:off x="502920" y="1325880"/>
+            <a:ext cx="3611880" cy="2103120"/>
+          </a:xfrm>
+          <a:prstGeom prst="roundRect">
+            <a:avLst>
+              <a:gd name="adj" fmla="val 2609"/>
+            </a:avLst>
+          </a:prstGeom>
+          <a:solidFill>
+            <a:srgbClr val="FFFFFF"/>
+          </a:solidFill>
+          <a:ln/>
+          <a:effectLst>
+            <a:outerShdw sx="100000" sy="100000" kx="0" ky="0" algn="bl" rotWithShape="0" blurRad="127000" dist="25400" dir="5400000">
+              <a:srgbClr val="0B1220">
+                <a:alpha val="5000"/>
+              </a:srgbClr>
+            </a:outerShdw>
+          </a:effectLst>
+        </p:spPr>
+      </p:sp>
+      <p:sp>
+        <p:nvSpPr>
+          <p:cNvPr id="6" name="Text 4"/>
+          <p:cNvSpPr/>
+          <p:nvPr/>
+        </p:nvSpPr>
+        <p:spPr>
+          <a:xfrm>
+            <a:off x="777240" y="1691640"/>
+            <a:ext cx="3063240" cy="411480"/>
+          </a:xfrm>
+          <a:prstGeom prst="rect">
+            <a:avLst/>
+          </a:prstGeom>
+          <a:noFill/>
+          <a:ln/>
+        </p:spPr>
+        <p:txBody>
+          <a:bodyPr wrap="square" lIns="0" tIns="0" rIns="0" bIns="0" rtlCol="0" anchor="ctr"/>
+          <a:lstStyle/>
+          <a:p>
+            <a:pPr indent="0" marL="0">
+              <a:buNone/>
+            </a:pPr>
+            <a:r>
+              <a:rPr lang="en-US" sz="1600" b="1" dirty="0">
+                <a:solidFill>
+                  <a:srgbClr val="0C2340"/>
+                </a:solidFill>
+                <a:latin typeface="Calibri" pitchFamily="34" charset="0"/>
+                <a:ea typeface="Calibri" pitchFamily="34" charset="-122"/>
+                <a:cs typeface="Calibri" pitchFamily="34" charset="-120"/>
+              </a:rPr>
+              <a:t>Time-to-rule</a:t>
+            </a:r>
+            <a:endParaRPr lang="en-US" sz="1600" dirty="0"/>
+          </a:p>
+        </p:txBody>
+      </p:sp>
+      <p:sp>
+        <p:nvSpPr>
+          <p:cNvPr id="7" name="Text 5"/>
+          <p:cNvSpPr/>
+          <p:nvPr/>
+        </p:nvSpPr>
+        <p:spPr>
+          <a:xfrm>
+            <a:off x="777240" y="2240280"/>
+            <a:ext cx="3063240" cy="914400"/>
+          </a:xfrm>
+          <a:prstGeom prst="rect">
+            <a:avLst/>
+          </a:prstGeom>
+          <a:noFill/>
+          <a:ln/>
+        </p:spPr>
+        <p:txBody>
+          <a:bodyPr wrap="square" lIns="0" tIns="0" rIns="0" bIns="0" rtlCol="0" anchor="ctr"/>
+          <a:lstStyle/>
+          <a:p>
+            <a:pPr indent="0" marL="0">
+              <a:buNone/>
+            </a:pPr>
+            <a:r>
+              <a:rPr lang="en-US" sz="1400" dirty="0">
+                <a:solidFill>
+                  <a:srgbClr val="334155"/>
+                </a:solidFill>
+                <a:latin typeface="Calibri" pitchFamily="34" charset="0"/>
+                <a:ea typeface="Calibri" pitchFamily="34" charset="-122"/>
+                <a:cs typeface="Calibri" pitchFamily="34" charset="-120"/>
+              </a:rPr>
+              <a:t>Change earn eligibility or rate in hours, not a release cycle.</a:t>
+            </a:r>
+            <a:endParaRPr lang="en-US" sz="1400" dirty="0"/>
+          </a:p>
+        </p:txBody>
+      </p:sp>
+      <p:sp>
+        <p:nvSpPr>
+          <p:cNvPr id="8" name="Shape 6"/>
+          <p:cNvSpPr/>
+          <p:nvPr/>
+        </p:nvSpPr>
+        <p:spPr>
+          <a:xfrm>
+            <a:off x="4343400" y="1325880"/>
+            <a:ext cx="3611880" cy="2103120"/>
+          </a:xfrm>
+          <a:prstGeom prst="roundRect">
+            <a:avLst>
+              <a:gd name="adj" fmla="val 2609"/>
+            </a:avLst>
+          </a:prstGeom>
+          <a:solidFill>
+            <a:srgbClr val="FFFFFF"/>
+          </a:solidFill>
+          <a:ln/>
+          <a:effectLst>
+            <a:outerShdw sx="100000" sy="100000" kx="0" ky="0" algn="bl" rotWithShape="0" blurRad="127000" dist="25400" dir="5400000">
+              <a:srgbClr val="0B1220">
+                <a:alpha val="5000"/>
+              </a:srgbClr>
+            </a:outerShdw>
+          </a:effectLst>
+        </p:spPr>
+      </p:sp>
+      <p:sp>
+        <p:nvSpPr>
+          <p:cNvPr id="9" name="Text 7"/>
+          <p:cNvSpPr/>
+          <p:nvPr/>
+        </p:nvSpPr>
+        <p:spPr>
+          <a:xfrm>
+            <a:off x="4617720" y="1691640"/>
+            <a:ext cx="3063240" cy="411480"/>
+          </a:xfrm>
+          <a:prstGeom prst="rect">
+            <a:avLst/>
+          </a:prstGeom>
+          <a:noFill/>
+          <a:ln/>
+        </p:spPr>
+        <p:txBody>
+          <a:bodyPr wrap="square" lIns="0" tIns="0" rIns="0" bIns="0" rtlCol="0" anchor="ctr"/>
+          <a:lstStyle/>
+          <a:p>
+            <a:pPr indent="0" marL="0">
+              <a:buNone/>
+            </a:pPr>
+            <a:r>
+              <a:rPr lang="en-US" sz="1600" b="1" dirty="0">
+                <a:solidFill>
+                  <a:srgbClr val="0C2340"/>
+                </a:solidFill>
+                <a:latin typeface="Calibri" pitchFamily="34" charset="0"/>
+                <a:ea typeface="Calibri" pitchFamily="34" charset="-122"/>
+                <a:cs typeface="Calibri" pitchFamily="34" charset="-120"/>
+              </a:rPr>
+              <a:t>Finance confidence</a:t>
+            </a:r>
+            <a:endParaRPr lang="en-US" sz="1600" dirty="0"/>
+          </a:p>
+        </p:txBody>
+      </p:sp>
+      <p:sp>
+        <p:nvSpPr>
+          <p:cNvPr id="10" name="Text 8"/>
+          <p:cNvSpPr/>
+          <p:nvPr/>
+        </p:nvSpPr>
+        <p:spPr>
+          <a:xfrm>
+            <a:off x="4617720" y="2240280"/>
+            <a:ext cx="3063240" cy="914400"/>
+          </a:xfrm>
+          <a:prstGeom prst="rect">
+            <a:avLst/>
+          </a:prstGeom>
+          <a:noFill/>
+          <a:ln/>
+        </p:spPr>
+        <p:txBody>
+          <a:bodyPr wrap="square" lIns="0" tIns="0" rIns="0" bIns="0" rtlCol="0" anchor="ctr"/>
+          <a:lstStyle/>
+          <a:p>
+            <a:pPr indent="0" marL="0">
+              <a:buNone/>
+            </a:pPr>
+            <a:r>
+              <a:rPr lang="en-US" sz="1400" dirty="0">
+                <a:solidFill>
+                  <a:srgbClr val="334155"/>
+                </a:solidFill>
+                <a:latin typeface="Calibri" pitchFamily="34" charset="0"/>
+                <a:ea typeface="Calibri" pitchFamily="34" charset="-122"/>
+                <a:cs typeface="Calibri" pitchFamily="34" charset="-120"/>
+              </a:rPr>
+              <a:t>Every points movement is balanced double-entry with queryable legs.</a:t>
+            </a:r>
+            <a:endParaRPr lang="en-US" sz="1400" dirty="0"/>
+          </a:p>
+        </p:txBody>
+      </p:sp>
+      <p:sp>
+        <p:nvSpPr>
+          <p:cNvPr id="11" name="Shape 9"/>
+          <p:cNvSpPr/>
+          <p:nvPr/>
+        </p:nvSpPr>
+        <p:spPr>
+          <a:xfrm>
+            <a:off x="8183880" y="1325880"/>
+            <a:ext cx="3611880" cy="2103120"/>
+          </a:xfrm>
+          <a:prstGeom prst="roundRect">
+            <a:avLst>
+              <a:gd name="adj" fmla="val 2609"/>
+            </a:avLst>
+          </a:prstGeom>
+          <a:solidFill>
+            <a:srgbClr val="FFFFFF"/>
+          </a:solidFill>
+          <a:ln/>
+          <a:effectLst>
+            <a:outerShdw sx="100000" sy="100000" kx="0" ky="0" algn="bl" rotWithShape="0" blurRad="127000" dist="25400" dir="5400000">
+              <a:srgbClr val="0B1220">
+                <a:alpha val="5000"/>
+              </a:srgbClr>
+            </a:outerShdw>
+          </a:effectLst>
+        </p:spPr>
+      </p:sp>
+      <p:sp>
+        <p:nvSpPr>
+          <p:cNvPr id="12" name="Text 10"/>
+          <p:cNvSpPr/>
+          <p:nvPr/>
+        </p:nvSpPr>
+        <p:spPr>
+          <a:xfrm>
+            <a:off x="8458200" y="1691640"/>
+            <a:ext cx="3063240" cy="411480"/>
+          </a:xfrm>
+          <a:prstGeom prst="rect">
+            <a:avLst/>
+          </a:prstGeom>
+          <a:noFill/>
+          <a:ln/>
+        </p:spPr>
+        <p:txBody>
+          <a:bodyPr wrap="square" lIns="0" tIns="0" rIns="0" bIns="0" rtlCol="0" anchor="ctr"/>
+          <a:lstStyle/>
+          <a:p>
+            <a:pPr indent="0" marL="0">
+              <a:buNone/>
+            </a:pPr>
+            <a:r>
+              <a:rPr lang="en-US" sz="1600" b="1" dirty="0">
+                <a:solidFill>
+                  <a:srgbClr val="0C2340"/>
+                </a:solidFill>
+                <a:latin typeface="Calibri" pitchFamily="34" charset="0"/>
+                <a:ea typeface="Calibri" pitchFamily="34" charset="-122"/>
+                <a:cs typeface="Calibri" pitchFamily="34" charset="-120"/>
+              </a:rPr>
+              <a:t>Channel leverage</a:t>
+            </a:r>
+            <a:endParaRPr lang="en-US" sz="1600" dirty="0"/>
+          </a:p>
+        </p:txBody>
+      </p:sp>
+      <p:sp>
+        <p:nvSpPr>
+          <p:cNvPr id="13" name="Text 11"/>
+          <p:cNvSpPr/>
+          <p:nvPr/>
+        </p:nvSpPr>
+        <p:spPr>
+          <a:xfrm>
+            <a:off x="8458200" y="2240280"/>
+            <a:ext cx="3063240" cy="914400"/>
+          </a:xfrm>
+          <a:prstGeom prst="rect">
+            <a:avLst/>
+          </a:prstGeom>
+          <a:noFill/>
+          <a:ln/>
+        </p:spPr>
+        <p:txBody>
+          <a:bodyPr wrap="square" lIns="0" tIns="0" rIns="0" bIns="0" rtlCol="0" anchor="ctr"/>
+          <a:lstStyle/>
+          <a:p>
+            <a:pPr indent="0" marL="0">
+              <a:buNone/>
+            </a:pPr>
+            <a:r>
+              <a:rPr lang="en-US" sz="1400" dirty="0">
+                <a:solidFill>
+                  <a:srgbClr val="334155"/>
+                </a:solidFill>
+                <a:latin typeface="Calibri" pitchFamily="34" charset="0"/>
+                <a:ea typeface="Calibri" pitchFamily="34" charset="-122"/>
+                <a:cs typeface="Calibri" pitchFamily="34" charset="-120"/>
+              </a:rPr>
+              <a:t>One event contract for POS, e-com, issuer — same Door/Brain/Books.</a:t>
+            </a:r>
+            <a:endParaRPr lang="en-US" sz="1400" dirty="0"/>
+          </a:p>
+        </p:txBody>
+      </p:sp>
+      <p:sp>
+        <p:nvSpPr>
+          <p:cNvPr id="14" name="Shape 12"/>
+          <p:cNvSpPr/>
+          <p:nvPr/>
+        </p:nvSpPr>
+        <p:spPr>
+          <a:xfrm>
+            <a:off x="502920" y="3657600"/>
+            <a:ext cx="3611880" cy="2103120"/>
+          </a:xfrm>
+          <a:prstGeom prst="roundRect">
+            <a:avLst>
+              <a:gd name="adj" fmla="val 2609"/>
+            </a:avLst>
+          </a:prstGeom>
+          <a:solidFill>
+            <a:srgbClr val="FFFFFF"/>
+          </a:solidFill>
+          <a:ln/>
+          <a:effectLst>
+            <a:outerShdw sx="100000" sy="100000" kx="0" ky="0" algn="bl" rotWithShape="0" blurRad="127000" dist="25400" dir="5400000">
+              <a:srgbClr val="0B1220">
+                <a:alpha val="5000"/>
+              </a:srgbClr>
+            </a:outerShdw>
+          </a:effectLst>
+        </p:spPr>
+      </p:sp>
+      <p:sp>
+        <p:nvSpPr>
+          <p:cNvPr id="15" name="Text 13"/>
+          <p:cNvSpPr/>
+          <p:nvPr/>
+        </p:nvSpPr>
+        <p:spPr>
+          <a:xfrm>
+            <a:off x="777240" y="4023360"/>
+            <a:ext cx="3063240" cy="411480"/>
+          </a:xfrm>
+          <a:prstGeom prst="rect">
+            <a:avLst/>
+          </a:prstGeom>
+          <a:noFill/>
+          <a:ln/>
+        </p:spPr>
+        <p:txBody>
+          <a:bodyPr wrap="square" lIns="0" tIns="0" rIns="0" bIns="0" rtlCol="0" anchor="ctr"/>
+          <a:lstStyle/>
+          <a:p>
+            <a:pPr indent="0" marL="0">
+              <a:buNone/>
+            </a:pPr>
+            <a:r>
+              <a:rPr lang="en-US" sz="1600" b="1" dirty="0">
+                <a:solidFill>
+                  <a:srgbClr val="0C2340"/>
+                </a:solidFill>
+                <a:latin typeface="Calibri" pitchFamily="34" charset="0"/>
+                <a:ea typeface="Calibri" pitchFamily="34" charset="-122"/>
+                <a:cs typeface="Calibri" pitchFamily="34" charset="-120"/>
+              </a:rPr>
+              <a:t>Operational clarity</a:t>
+            </a:r>
+            <a:endParaRPr lang="en-US" sz="1600" dirty="0"/>
+          </a:p>
+        </p:txBody>
+      </p:sp>
+      <p:sp>
+        <p:nvSpPr>
+          <p:cNvPr id="16" name="Text 14"/>
+          <p:cNvSpPr/>
+          <p:nvPr/>
+        </p:nvSpPr>
+        <p:spPr>
+          <a:xfrm>
+            <a:off x="777240" y="4572000"/>
+            <a:ext cx="3063240" cy="914400"/>
+          </a:xfrm>
+          <a:prstGeom prst="rect">
+            <a:avLst/>
+          </a:prstGeom>
+          <a:noFill/>
+          <a:ln/>
+        </p:spPr>
+        <p:txBody>
+          <a:bodyPr wrap="square" lIns="0" tIns="0" rIns="0" bIns="0" rtlCol="0" anchor="ctr"/>
+          <a:lstStyle/>
+          <a:p>
+            <a:pPr indent="0" marL="0">
+              <a:buNone/>
+            </a:pPr>
+            <a:r>
+              <a:rPr lang="en-US" sz="1400" dirty="0">
+                <a:solidFill>
+                  <a:srgbClr val="334155"/>
+                </a:solidFill>
+                <a:latin typeface="Calibri" pitchFamily="34" charset="0"/>
+                <a:ea typeface="Calibri" pitchFamily="34" charset="-122"/>
+                <a:cs typeface="Calibri" pitchFamily="34" charset="-120"/>
+              </a:rPr>
+              <a:t>Dry-run and skip traces reduce ‘why no points?’ tickets.</a:t>
+            </a:r>
+            <a:endParaRPr lang="en-US" sz="1400" dirty="0"/>
+          </a:p>
+        </p:txBody>
+      </p:sp>
+      <p:sp>
+        <p:nvSpPr>
+          <p:cNvPr id="17" name="Shape 15"/>
+          <p:cNvSpPr/>
+          <p:nvPr/>
+        </p:nvSpPr>
+        <p:spPr>
+          <a:xfrm>
+            <a:off x="4343400" y="3657600"/>
+            <a:ext cx="3611880" cy="2103120"/>
+          </a:xfrm>
+          <a:prstGeom prst="roundRect">
+            <a:avLst>
+              <a:gd name="adj" fmla="val 2609"/>
+            </a:avLst>
+          </a:prstGeom>
+          <a:solidFill>
+            <a:srgbClr val="FFFFFF"/>
+          </a:solidFill>
+          <a:ln/>
+          <a:effectLst>
+            <a:outerShdw sx="100000" sy="100000" kx="0" ky="0" algn="bl" rotWithShape="0" blurRad="127000" dist="25400" dir="5400000">
+              <a:srgbClr val="0B1220">
+                <a:alpha val="5000"/>
+              </a:srgbClr>
+            </a:outerShdw>
+          </a:effectLst>
+        </p:spPr>
+      </p:sp>
+      <p:sp>
+        <p:nvSpPr>
+          <p:cNvPr id="18" name="Text 16"/>
+          <p:cNvSpPr/>
+          <p:nvPr/>
+        </p:nvSpPr>
+        <p:spPr>
+          <a:xfrm>
+            <a:off x="4617720" y="4023360"/>
+            <a:ext cx="3063240" cy="411480"/>
+          </a:xfrm>
+          <a:prstGeom prst="rect">
+            <a:avLst/>
+          </a:prstGeom>
+          <a:noFill/>
+          <a:ln/>
+        </p:spPr>
+        <p:txBody>
+          <a:bodyPr wrap="square" lIns="0" tIns="0" rIns="0" bIns="0" rtlCol="0" anchor="ctr"/>
+          <a:lstStyle/>
+          <a:p>
+            <a:pPr indent="0" marL="0">
+              <a:buNone/>
+            </a:pPr>
+            <a:r>
+              <a:rPr lang="en-US" sz="1600" b="1" dirty="0">
+                <a:solidFill>
+                  <a:srgbClr val="0C2340"/>
+                </a:solidFill>
+                <a:latin typeface="Calibri" pitchFamily="34" charset="0"/>
+                <a:ea typeface="Calibri" pitchFamily="34" charset="-122"/>
+                <a:cs typeface="Calibri" pitchFamily="34" charset="-120"/>
+              </a:rPr>
+              <a:t>Clean boundaries</a:t>
+            </a:r>
+            <a:endParaRPr lang="en-US" sz="1600" dirty="0"/>
+          </a:p>
+        </p:txBody>
+      </p:sp>
+      <p:sp>
+        <p:nvSpPr>
+          <p:cNvPr id="19" name="Text 17"/>
+          <p:cNvSpPr/>
+          <p:nvPr/>
+        </p:nvSpPr>
+        <p:spPr>
+          <a:xfrm>
+            <a:off x="4617720" y="4572000"/>
+            <a:ext cx="3063240" cy="914400"/>
+          </a:xfrm>
+          <a:prstGeom prst="rect">
+            <a:avLst/>
+          </a:prstGeom>
+          <a:noFill/>
+          <a:ln/>
+        </p:spPr>
+        <p:txBody>
+          <a:bodyPr wrap="square" lIns="0" tIns="0" rIns="0" bIns="0" rtlCol="0" anchor="ctr"/>
+          <a:lstStyle/>
+          <a:p>
+            <a:pPr indent="0" marL="0">
+              <a:buNone/>
+            </a:pPr>
+            <a:r>
+              <a:rPr lang="en-US" sz="1400" dirty="0">
+                <a:solidFill>
+                  <a:srgbClr val="334155"/>
+                </a:solidFill>
+                <a:latin typeface="Calibri" pitchFamily="34" charset="0"/>
+                <a:ea typeface="Calibri" pitchFamily="34" charset="-122"/>
+                <a:cs typeface="Calibri" pitchFamily="34" charset="-120"/>
+              </a:rPr>
+              <a:t>CRM stays CRM; payments stay payments; ledger stays ledger.</a:t>
+            </a:r>
+            <a:endParaRPr lang="en-US" sz="1400" dirty="0"/>
+          </a:p>
+        </p:txBody>
+      </p:sp>
+      <p:sp>
+        <p:nvSpPr>
+          <p:cNvPr id="20" name="Shape 18"/>
+          <p:cNvSpPr/>
+          <p:nvPr/>
+        </p:nvSpPr>
+        <p:spPr>
+          <a:xfrm>
+            <a:off x="8183880" y="3657600"/>
+            <a:ext cx="3611880" cy="2103120"/>
+          </a:xfrm>
+          <a:prstGeom prst="roundRect">
+            <a:avLst>
+              <a:gd name="adj" fmla="val 2609"/>
+            </a:avLst>
+          </a:prstGeom>
+          <a:solidFill>
+            <a:srgbClr val="FFFFFF"/>
+          </a:solidFill>
+          <a:ln/>
+          <a:effectLst>
+            <a:outerShdw sx="100000" sy="100000" kx="0" ky="0" algn="bl" rotWithShape="0" blurRad="127000" dist="25400" dir="5400000">
+              <a:srgbClr val="0B1220">
+                <a:alpha val="5000"/>
+              </a:srgbClr>
+            </a:outerShdw>
+          </a:effectLst>
+        </p:spPr>
+      </p:sp>
+      <p:sp>
+        <p:nvSpPr>
+          <p:cNvPr id="21" name="Text 19"/>
+          <p:cNvSpPr/>
+          <p:nvPr/>
+        </p:nvSpPr>
+        <p:spPr>
+          <a:xfrm>
+            <a:off x="8458200" y="4023360"/>
+            <a:ext cx="3063240" cy="411480"/>
+          </a:xfrm>
+          <a:prstGeom prst="rect">
+            <a:avLst/>
+          </a:prstGeom>
+          <a:noFill/>
+          <a:ln/>
+        </p:spPr>
+        <p:txBody>
+          <a:bodyPr wrap="square" lIns="0" tIns="0" rIns="0" bIns="0" rtlCol="0" anchor="ctr"/>
+          <a:lstStyle/>
+          <a:p>
+            <a:pPr indent="0" marL="0">
+              <a:buNone/>
+            </a:pPr>
+            <a:r>
+              <a:rPr lang="en-US" sz="1600" b="1" dirty="0">
+                <a:solidFill>
+                  <a:srgbClr val="0C2340"/>
+                </a:solidFill>
+                <a:latin typeface="Calibri" pitchFamily="34" charset="0"/>
+                <a:ea typeface="Calibri" pitchFamily="34" charset="-122"/>
+                <a:cs typeface="Calibri" pitchFamily="34" charset="-120"/>
+              </a:rPr>
+              <a:t>Platform fit</a:t>
+            </a:r>
+            <a:endParaRPr lang="en-US" sz="1600" dirty="0"/>
+          </a:p>
+        </p:txBody>
+      </p:sp>
+      <p:sp>
+        <p:nvSpPr>
+          <p:cNvPr id="22" name="Text 20"/>
+          <p:cNvSpPr/>
+          <p:nvPr/>
+        </p:nvSpPr>
+        <p:spPr>
+          <a:xfrm>
+            <a:off x="8458200" y="4572000"/>
+            <a:ext cx="3063240" cy="914400"/>
+          </a:xfrm>
+          <a:prstGeom prst="rect">
+            <a:avLst/>
+          </a:prstGeom>
+          <a:noFill/>
+          <a:ln/>
+        </p:spPr>
+        <p:txBody>
+          <a:bodyPr wrap="square" lIns="0" tIns="0" rIns="0" bIns="0" rtlCol="0" anchor="ctr"/>
+          <a:lstStyle/>
+          <a:p>
+            <a:pPr indent="0" marL="0">
+              <a:buNone/>
+            </a:pPr>
+            <a:r>
+              <a:rPr lang="en-US" sz="1400" dirty="0">
+                <a:solidFill>
+                  <a:srgbClr val="334155"/>
+                </a:solidFill>
+                <a:latin typeface="Calibri" pitchFamily="34" charset="0"/>
+                <a:ea typeface="Calibri" pitchFamily="34" charset="-122"/>
+                <a:cs typeface="Calibri" pitchFamily="34" charset="-120"/>
+              </a:rPr>
+              <a:t>Drops in as a domain microservice inside the existing cluster.</a:t>
+            </a:r>
+            <a:endParaRPr lang="en-US" sz="1400" dirty="0"/>
+          </a:p>
+        </p:txBody>
+      </p:sp>
+      <p:sp>
+        <p:nvSpPr>
+          <p:cNvPr id="23" name="Text 21"/>
+          <p:cNvSpPr/>
+          <p:nvPr/>
+        </p:nvSpPr>
+        <p:spPr>
+          <a:xfrm>
+            <a:off x="502920" y="6510528"/>
+            <a:ext cx="8229600" cy="201168"/>
+          </a:xfrm>
+          <a:prstGeom prst="rect">
+            <a:avLst/>
+          </a:prstGeom>
+          <a:noFill/>
+          <a:ln/>
+        </p:spPr>
+        <p:txBody>
+          <a:bodyPr wrap="square" lIns="0" tIns="0" rIns="0" bIns="0" rtlCol="0" anchor="ctr"/>
+          <a:lstStyle/>
+          <a:p>
+            <a:pPr indent="0" marL="0">
+              <a:buNone/>
+            </a:pPr>
+            <a:r>
+              <a:rPr lang="en-US" sz="1000" dirty="0">
+                <a:solidFill>
+                  <a:srgbClr val="64748B"/>
+                </a:solidFill>
+                <a:latin typeface="Calibri" pitchFamily="34" charset="0"/>
+                <a:ea typeface="Calibri" pitchFamily="34" charset="-122"/>
+                <a:cs typeface="Calibri" pitchFamily="34" charset="-120"/>
+              </a:rPr>
+              <a:t>LedgeRX  |  Executive briefing</a:t>
+            </a:r>
+            <a:endParaRPr lang="en-US" sz="1000" dirty="0"/>
+          </a:p>
+        </p:txBody>
+      </p:sp>
+      <p:sp>
+        <p:nvSpPr>
+          <p:cNvPr id="24" name="Text 22"/>
+          <p:cNvSpPr/>
+          <p:nvPr/>
+        </p:nvSpPr>
+        <p:spPr>
+          <a:xfrm>
+            <a:off x="11155680" y="6510528"/>
+            <a:ext cx="548640" cy="201168"/>
+          </a:xfrm>
+          <a:prstGeom prst="rect">
+            <a:avLst/>
+          </a:prstGeom>
+          <a:noFill/>
+          <a:ln/>
+        </p:spPr>
+        <p:txBody>
+          <a:bodyPr wrap="square" lIns="0" tIns="0" rIns="0" bIns="0" rtlCol="0" anchor="ctr"/>
+          <a:lstStyle/>
+          <a:p>
+            <a:pPr algn="r" indent="0" marL="0">
+              <a:buNone/>
+            </a:pPr>
+            <a:r>
+              <a:rPr lang="en-US" sz="1000" dirty="0">
+                <a:solidFill>
+                  <a:srgbClr val="64748B"/>
+                </a:solidFill>
+                <a:latin typeface="Calibri" pitchFamily="34" charset="0"/>
+                <a:ea typeface="Calibri" pitchFamily="34" charset="-122"/>
+                <a:cs typeface="Calibri" pitchFamily="34" charset="-120"/>
+              </a:rPr>
+              <a:t>13</a:t>
+            </a:r>
+            <a:endParaRPr lang="en-US" sz="1000" dirty="0"/>
+          </a:p>
+        </p:txBody>
+      </p:sp>
+    </p:spTree>
+  </p:cSld>
+  <p:clrMapOvr>
+    <a:masterClrMapping/>
+  </p:clrMapOvr>
+</p:sld>
+</file>
+
+<file path=ppt/slides/slide14.xml><?xml version="1.0" encoding="utf-8"?>
+<p:sld xmlns:a="http://schemas.openxmlformats.org/drawingml/2006/main" xmlns:r="http://schemas.openxmlformats.org/officeDocument/2006/relationships" xmlns:p="http://schemas.openxmlformats.org/presentationml/2006/main">
+  <p:cSld name="Slide 14">
+    <p:spTree>
+      <p:nvGrpSpPr>
+        <p:cNvPr id="1" name=""/>
+        <p:cNvGrpSpPr/>
+        <p:nvPr/>
+      </p:nvGrpSpPr>
+      <p:grpSpPr>
+        <a:xfrm>
+          <a:off x="0" y="0"/>
+          <a:ext cx="0" cy="0"/>
+          <a:chOff x="0" y="0"/>
+          <a:chExt cx="0" cy="0"/>
+        </a:xfrm>
+      </p:grpSpPr>
+      <p:sp>
+        <p:nvSpPr>
+          <p:cNvPr id="2" name="Shape 0"/>
+          <p:cNvSpPr/>
+          <p:nvPr/>
+        </p:nvSpPr>
+        <p:spPr>
+          <a:xfrm>
+            <a:off x="0" y="0"/>
+            <a:ext cx="12161520" cy="6858000"/>
+          </a:xfrm>
+          <a:prstGeom prst="rect">
+            <a:avLst/>
+          </a:prstGeom>
+          <a:solidFill>
             <a:srgbClr val="0C2340"/>
           </a:solidFill>
           <a:ln/>
@@ -4420,8 +6978,8 @@
         </p:nvSpPr>
         <p:spPr>
           <a:xfrm>
-            <a:off x="640080" y="1828800"/>
-            <a:ext cx="10972800" cy="365760"/>
+            <a:off x="640080" y="1737360"/>
+            <a:ext cx="10972800" cy="320040"/>
           </a:xfrm>
           <a:prstGeom prst="rect">
             <a:avLst/>
@@ -4459,8 +7017,8 @@
         </p:nvSpPr>
         <p:spPr>
           <a:xfrm>
-            <a:off x="640080" y="2331720"/>
-            <a:ext cx="10789920" cy="1097280"/>
+            <a:off x="640080" y="2194560"/>
+            <a:ext cx="10789920" cy="1371600"/>
           </a:xfrm>
           <a:prstGeom prst="rect">
             <a:avLst/>
@@ -4484,7 +7042,7 @@
                 <a:ea typeface="Calibri" pitchFamily="34" charset="-122"/>
                 <a:cs typeface="Calibri" pitchFamily="34" charset="-120"/>
               </a:rPr>
-              <a:t>LedgeRX is the programme’s balance system of record —</a:t>
+              <a:t>LedgeRX is the programme’s balance domain service —</a:t>
             </a:r>
             <a:endParaRPr lang="en-US" sz="2400" dirty="0"/>
           </a:p>
@@ -4501,7 +7059,24 @@
                 <a:ea typeface="Calibri" pitchFamily="34" charset="-122"/>
                 <a:cs typeface="Calibri" pitchFamily="34" charset="-120"/>
               </a:rPr>
-              <a:t>configure rules at runtime, post double-entry, integrate on events.</a:t>
+              <a:t>runtime rules, double-entry books, event-based integration</a:t>
+            </a:r>
+            <a:endParaRPr lang="en-US" sz="2400" dirty="0"/>
+          </a:p>
+          <a:p>
+            <a:pPr indent="0" marL="0">
+              <a:buNone/>
+            </a:pPr>
+            <a:r>
+              <a:rPr lang="en-US" sz="2400" b="1" dirty="0">
+                <a:solidFill>
+                  <a:srgbClr val="FFFFFF"/>
+                </a:solidFill>
+                <a:latin typeface="Calibri" pitchFamily="34" charset="0"/>
+                <a:ea typeface="Calibri" pitchFamily="34" charset="-122"/>
+                <a:cs typeface="Calibri" pitchFamily="34" charset="-120"/>
+              </a:rPr>
+              <a:t>inside your microservices platform.</a:t>
             </a:r>
             <a:endParaRPr lang="en-US" sz="2400" dirty="0"/>
           </a:p>
@@ -4540,7 +7115,7 @@
                 <a:ea typeface="Calibri" pitchFamily="34" charset="-122"/>
                 <a:cs typeface="Calibri" pitchFamily="34" charset="-120"/>
               </a:rPr>
-              <a:t>Recommended read: docs/START_HERE.md   ·   Engine: ledger-engine</a:t>
+              <a:t>docs/START_HERE.md   ·   module ledger-engine   ·   in-cluster</a:t>
             </a:r>
             <a:endParaRPr lang="en-US" sz="1400" dirty="0"/>
           </a:p>
@@ -5208,7 +7783,7 @@
                 <a:ea typeface="Calibri" pitchFamily="34" charset="-122"/>
                 <a:cs typeface="Calibri" pitchFamily="34" charset="-120"/>
               </a:rPr>
-              <a:t>How it integrates</a:t>
+              <a:t>Integration</a:t>
             </a:r>
             <a:endParaRPr lang="en-US" sz="1800" dirty="0"/>
           </a:p>
@@ -5354,7 +7929,7 @@
                 <a:ea typeface="Calibri" pitchFamily="34" charset="-122"/>
                 <a:cs typeface="Calibri" pitchFamily="34" charset="-120"/>
               </a:rPr>
-              <a:t>Capability &amp; architecture</a:t>
+              <a:t>Capabilities</a:t>
             </a:r>
             <a:endParaRPr lang="en-US" sz="1800" dirty="0"/>
           </a:p>
@@ -5393,7 +7968,7 @@
                 <a:ea typeface="Calibri" pitchFamily="34" charset="-122"/>
                 <a:cs typeface="Calibri" pitchFamily="34" charset="-120"/>
               </a:rPr>
-              <a:t>Door → Brain → Books</a:t>
+              <a:t>Door · Brain · Wallet · Books · Trust</a:t>
             </a:r>
             <a:endParaRPr lang="en-US" sz="1300" dirty="0"/>
           </a:p>
@@ -5500,7 +8075,7 @@
                 <a:ea typeface="Calibri" pitchFamily="34" charset="-122"/>
                 <a:cs typeface="Calibri" pitchFamily="34" charset="-120"/>
               </a:rPr>
-              <a:t>Value &amp; next steps</a:t>
+              <a:t>Architecture</a:t>
             </a:r>
             <a:endParaRPr lang="en-US" sz="1800" dirty="0"/>
           </a:p>
@@ -5539,7 +8114,7 @@
                 <a:ea typeface="Calibri" pitchFamily="34" charset="-122"/>
                 <a:cs typeface="Calibri" pitchFamily="34" charset="-120"/>
               </a:rPr>
-              <a:t>Outcomes for the business</a:t>
+              <a:t>Pipeline + microservices landscape</a:t>
             </a:r>
             <a:endParaRPr lang="en-US" sz="1300" dirty="0"/>
           </a:p>
@@ -5740,7 +8315,7 @@
                 <a:ea typeface="Calibri" pitchFamily="34" charset="-122"/>
                 <a:cs typeface="Calibri" pitchFamily="34" charset="-120"/>
               </a:rPr>
-              <a:t>Loyalty points are financial liabilities — but often run on spreadsheets or bolt-ons</a:t>
+              <a:t>Loyalty points are financial liabilities — often run on spreadsheets or bolt-ons</a:t>
             </a:r>
             <a:endParaRPr lang="en-US" sz="1400" dirty="0"/>
           </a:p>
@@ -6525,7 +9100,7 @@
                 <a:ea typeface="Calibri" pitchFamily="34" charset="-122"/>
                 <a:cs typeface="Calibri" pitchFamily="34" charset="-120"/>
               </a:rPr>
-              <a:t>A dedicated system of record for programme balances</a:t>
+              <a:t>A dedicated domain service for programme balances</a:t>
             </a:r>
             <a:endParaRPr lang="en-US" sz="1400" dirty="0"/>
           </a:p>
@@ -9491,7 +12066,7 @@
                 <a:ea typeface="Calibri" pitchFamily="34" charset="-122"/>
                 <a:cs typeface="Calibri" pitchFamily="34" charset="-120"/>
               </a:rPr>
-              <a:t>COA profiles (e.g. STREAM_A / STREAM_B) stamp segment codes when books open. Points math stays in Brain. Product APIs do not leak internal COA segments to members.</a:t>
+              <a:t>COA profiles stamp segment codes when books open. Points math stays in Brain. Product APIs do not leak internal COA segments to members.</a:t>
             </a:r>
             <a:endParaRPr lang="en-US" sz="1400" dirty="0"/>
           </a:p>
@@ -10268,7 +12843,7 @@
                 <a:ea typeface="Calibri" pitchFamily="34" charset="-122"/>
                 <a:cs typeface="Calibri" pitchFamily="34" charset="-120"/>
               </a:rPr>
-              <a:t>ownerId + settlement currency + optional COA</a:t>
+              <a:t>ownerId + settlement + optional COA</a:t>
             </a:r>
             <a:endParaRPr lang="en-US" sz="1300" dirty="0"/>
           </a:p>

</xml_diff>

<commit_message>
docs: appendix sequence board split into 2 slides (earn + burn halves)
</commit_message>
<xml_diff>
--- a/docs/decks/LedgeRX-Executive-Briefing-v2.pptx
+++ b/docs/decks/LedgeRX-Executive-Briefing-v2.pptx
@@ -28,6 +28,9 @@
     <p:sldId id="276" r:id="rId22"/>
     <p:sldId id="277" r:id="rId23"/>
     <p:sldId id="278" r:id="rId24"/>
+    <p:sldId id="279" r:id="rId30"/>
+    <p:sldId id="280" r:id="rId31"/>
+    <p:sldId id="281" r:id="rId32"/>
   </p:sldIdLst>
   <p:notesMasterIdLst>
     <p:notesMasterId r:id="rId25"/>
@@ -24719,6 +24722,361 @@
 </p:sld>
 </file>
 
+<file path=ppt/slides/slide24.xml><?xml version="1.0" encoding="utf-8"?>
+<p:sld xmlns:a="http://schemas.openxmlformats.org/drawingml/2006/main" xmlns:p="http://schemas.openxmlformats.org/presentationml/2006/main" xmlns:r="http://schemas.openxmlformats.org/officeDocument/2006/relationships">
+  <p:cSld>
+    <p:spTree>
+      <p:nvGrpSpPr>
+        <p:cNvPr id="1" name=""/>
+        <p:cNvGrpSpPr/>
+        <p:nvPr/>
+      </p:nvGrpSpPr>
+      <p:grpSpPr/>
+      <p:sp>
+        <p:nvSpPr>
+          <p:cNvPr id="2" name="Rectangle 1"/>
+          <p:cNvSpPr/>
+          <p:nvPr/>
+        </p:nvSpPr>
+        <p:spPr>
+          <a:xfrm>
+            <a:off x="0" y="0"/>
+            <a:ext cx="12192000" cy="6858000"/>
+          </a:xfrm>
+          <a:prstGeom prst="rect">
+            <a:avLst/>
+          </a:prstGeom>
+          <a:solidFill>
+            <a:srgbClr val="0C2340"/>
+          </a:solidFill>
+          <a:ln>
+            <a:noFill/>
+          </a:ln>
+        </p:spPr>
+        <p:style>
+          <a:lnRef idx="1">
+            <a:schemeClr val="accent1"/>
+          </a:lnRef>
+          <a:fillRef idx="3">
+            <a:schemeClr val="accent1"/>
+          </a:fillRef>
+          <a:effectRef idx="2">
+            <a:schemeClr val="accent1"/>
+          </a:effectRef>
+          <a:fontRef idx="minor">
+            <a:schemeClr val="lt1"/>
+          </a:fontRef>
+        </p:style>
+        <p:txBody>
+          <a:bodyPr rtlCol="0" anchor="ctr"/>
+          <a:lstStyle/>
+          <a:p>
+            <a:pPr algn="ctr"/>
+          </a:p>
+        </p:txBody>
+      </p:sp>
+      <p:sp>
+        <p:nvSpPr>
+          <p:cNvPr id="3" name="TextBox 2"/>
+          <p:cNvSpPr txBox="1"/>
+          <p:nvPr/>
+        </p:nvSpPr>
+        <p:spPr>
+          <a:xfrm>
+            <a:off x="640080" y="2286000"/>
+            <a:ext cx="10972800" cy="2286000"/>
+          </a:xfrm>
+          <a:prstGeom prst="rect">
+            <a:avLst/>
+          </a:prstGeom>
+          <a:noFill/>
+        </p:spPr>
+        <p:txBody>
+          <a:bodyPr wrap="square">
+            <a:spAutoFit/>
+          </a:bodyPr>
+          <a:lstStyle/>
+          <a:p>
+            <a:r>
+              <a:rPr sz="1600" b="1">
+                <a:solidFill>
+                  <a:srgbClr val="14B8A6"/>
+                </a:solidFill>
+                <a:latin typeface="Calibri"/>
+              </a:rPr>
+              <a:t>APPENDIX</a:t>
+            </a:r>
+          </a:p>
+          <a:p>
+            <a:r>
+              <a:rPr sz="3200" b="1">
+                <a:solidFill>
+                  <a:srgbClr val="FFFFFF"/>
+                </a:solidFill>
+                <a:latin typeface="Calibri"/>
+              </a:rPr>
+              <a:t>Earn · Process · Burn — full sequence board</a:t>
+            </a:r>
+          </a:p>
+          <a:p>
+            <a:r>
+              <a:rPr sz="1800">
+                <a:solidFill>
+                  <a:srgbClr val="94A3B8"/>
+                </a:solidFill>
+                <a:latin typeface="Calibri"/>
+              </a:rPr>
+              <a:t>Split into 2 slides (readable HTML board)</a:t>
+            </a:r>
+          </a:p>
+        </p:txBody>
+      </p:sp>
+    </p:spTree>
+  </p:cSld>
+  <p:clrMapOvr>
+    <a:masterClrMapping/>
+  </p:clrMapOvr>
+</p:sld>
+</file>
+
+<file path=ppt/slides/slide25.xml><?xml version="1.0" encoding="utf-8"?>
+<p:sld xmlns:a="http://schemas.openxmlformats.org/drawingml/2006/main" xmlns:p="http://schemas.openxmlformats.org/presentationml/2006/main" xmlns:r="http://schemas.openxmlformats.org/officeDocument/2006/relationships">
+  <p:cSld>
+    <p:spTree>
+      <p:nvGrpSpPr>
+        <p:cNvPr id="1" name=""/>
+        <p:cNvGrpSpPr/>
+        <p:nvPr/>
+      </p:nvGrpSpPr>
+      <p:grpSpPr/>
+      <p:sp>
+        <p:nvSpPr>
+          <p:cNvPr id="2" name="Rectangle 1"/>
+          <p:cNvSpPr/>
+          <p:nvPr/>
+        </p:nvSpPr>
+        <p:spPr>
+          <a:xfrm>
+            <a:off x="0" y="0"/>
+            <a:ext cx="12192000" cy="6858000"/>
+          </a:xfrm>
+          <a:prstGeom prst="rect">
+            <a:avLst/>
+          </a:prstGeom>
+          <a:solidFill>
+            <a:srgbClr val="0B1220"/>
+          </a:solidFill>
+          <a:ln>
+            <a:noFill/>
+          </a:ln>
+        </p:spPr>
+        <p:style>
+          <a:lnRef idx="1">
+            <a:schemeClr val="accent1"/>
+          </a:lnRef>
+          <a:fillRef idx="3">
+            <a:schemeClr val="accent1"/>
+          </a:fillRef>
+          <a:effectRef idx="2">
+            <a:schemeClr val="accent1"/>
+          </a:effectRef>
+          <a:fontRef idx="minor">
+            <a:schemeClr val="lt1"/>
+          </a:fontRef>
+        </p:style>
+        <p:txBody>
+          <a:bodyPr rtlCol="0" anchor="ctr"/>
+          <a:lstStyle/>
+          <a:p>
+            <a:pPr algn="ctr"/>
+          </a:p>
+        </p:txBody>
+      </p:sp>
+      <p:sp>
+        <p:nvSpPr>
+          <p:cNvPr id="3" name="TextBox 2"/>
+          <p:cNvSpPr txBox="1"/>
+          <p:nvPr/>
+        </p:nvSpPr>
+        <p:spPr>
+          <a:xfrm>
+            <a:off x="365760" y="109728"/>
+            <a:ext cx="11430000" cy="320040"/>
+          </a:xfrm>
+          <a:prstGeom prst="rect">
+            <a:avLst/>
+          </a:prstGeom>
+          <a:noFill/>
+        </p:spPr>
+        <p:txBody>
+          <a:bodyPr wrap="none">
+            <a:spAutoFit/>
+          </a:bodyPr>
+          <a:lstStyle/>
+          <a:p>
+            <a:r>
+              <a:rPr sz="1300" b="1">
+                <a:solidFill>
+                  <a:srgbClr val="14B8A6"/>
+                </a:solidFill>
+                <a:latin typeface="Calibri"/>
+              </a:rPr>
+              <a:t>APPENDIX A1  ·  Sequence board (1/2)  ·  Transaction → Earn</a:t>
+            </a:r>
+          </a:p>
+        </p:txBody>
+      </p:sp>
+      <p:pic>
+        <p:nvPicPr>
+          <p:cNvPr id="4" name="Picture 3" descr="uaf-earn-burn-appendix-1.png"/>
+          <p:cNvPicPr>
+            <a:picLocks noChangeAspect="1"/>
+          </p:cNvPicPr>
+          <p:nvPr/>
+        </p:nvPicPr>
+        <p:blipFill>
+          <a:blip r:embed="rId2"/>
+          <a:stretch>
+            <a:fillRect/>
+          </a:stretch>
+        </p:blipFill>
+        <p:spPr>
+          <a:xfrm>
+            <a:off x="3883495" y="548639"/>
+            <a:ext cx="4394528" cy="5943600"/>
+          </a:xfrm>
+          <a:prstGeom prst="rect">
+            <a:avLst/>
+          </a:prstGeom>
+        </p:spPr>
+      </p:pic>
+    </p:spTree>
+  </p:cSld>
+  <p:clrMapOvr>
+    <a:masterClrMapping/>
+  </p:clrMapOvr>
+</p:sld>
+</file>
+
+<file path=ppt/slides/slide26.xml><?xml version="1.0" encoding="utf-8"?>
+<p:sld xmlns:a="http://schemas.openxmlformats.org/drawingml/2006/main" xmlns:p="http://schemas.openxmlformats.org/presentationml/2006/main" xmlns:r="http://schemas.openxmlformats.org/officeDocument/2006/relationships">
+  <p:cSld>
+    <p:spTree>
+      <p:nvGrpSpPr>
+        <p:cNvPr id="1" name=""/>
+        <p:cNvGrpSpPr/>
+        <p:nvPr/>
+      </p:nvGrpSpPr>
+      <p:grpSpPr/>
+      <p:sp>
+        <p:nvSpPr>
+          <p:cNvPr id="2" name="Rectangle 1"/>
+          <p:cNvSpPr/>
+          <p:nvPr/>
+        </p:nvSpPr>
+        <p:spPr>
+          <a:xfrm>
+            <a:off x="0" y="0"/>
+            <a:ext cx="12192000" cy="6858000"/>
+          </a:xfrm>
+          <a:prstGeom prst="rect">
+            <a:avLst/>
+          </a:prstGeom>
+          <a:solidFill>
+            <a:srgbClr val="0B1220"/>
+          </a:solidFill>
+          <a:ln>
+            <a:noFill/>
+          </a:ln>
+        </p:spPr>
+        <p:style>
+          <a:lnRef idx="1">
+            <a:schemeClr val="accent1"/>
+          </a:lnRef>
+          <a:fillRef idx="3">
+            <a:schemeClr val="accent1"/>
+          </a:fillRef>
+          <a:effectRef idx="2">
+            <a:schemeClr val="accent1"/>
+          </a:effectRef>
+          <a:fontRef idx="minor">
+            <a:schemeClr val="lt1"/>
+          </a:fontRef>
+        </p:style>
+        <p:txBody>
+          <a:bodyPr rtlCol="0" anchor="ctr"/>
+          <a:lstStyle/>
+          <a:p>
+            <a:pPr algn="ctr"/>
+          </a:p>
+        </p:txBody>
+      </p:sp>
+      <p:sp>
+        <p:nvSpPr>
+          <p:cNvPr id="3" name="TextBox 2"/>
+          <p:cNvSpPr txBox="1"/>
+          <p:nvPr/>
+        </p:nvSpPr>
+        <p:spPr>
+          <a:xfrm>
+            <a:off x="365760" y="109728"/>
+            <a:ext cx="11430000" cy="320040"/>
+          </a:xfrm>
+          <a:prstGeom prst="rect">
+            <a:avLst/>
+          </a:prstGeom>
+          <a:noFill/>
+        </p:spPr>
+        <p:txBody>
+          <a:bodyPr wrap="none">
+            <a:spAutoFit/>
+          </a:bodyPr>
+          <a:lstStyle/>
+          <a:p>
+            <a:r>
+              <a:rPr sz="1300" b="1">
+                <a:solidFill>
+                  <a:srgbClr val="14B8A6"/>
+                </a:solidFill>
+                <a:latin typeface="Calibri"/>
+              </a:rPr>
+              <a:t>APPENDIX A2  ·  Sequence board (2/2)  ·  Result → Burn + summary</a:t>
+            </a:r>
+          </a:p>
+        </p:txBody>
+      </p:sp>
+      <p:pic>
+        <p:nvPicPr>
+          <p:cNvPr id="4" name="Picture 3" descr="uaf-earn-burn-appendix-2.png"/>
+          <p:cNvPicPr>
+            <a:picLocks noChangeAspect="1"/>
+          </p:cNvPicPr>
+          <p:nvPr/>
+        </p:nvPicPr>
+        <p:blipFill>
+          <a:blip r:embed="rId2"/>
+          <a:stretch>
+            <a:fillRect/>
+          </a:stretch>
+        </p:blipFill>
+        <p:spPr>
+          <a:xfrm>
+            <a:off x="3150472" y="548639"/>
+            <a:ext cx="5860575" cy="5943600"/>
+          </a:xfrm>
+          <a:prstGeom prst="rect">
+            <a:avLst/>
+          </a:prstGeom>
+        </p:spPr>
+      </p:pic>
+    </p:spTree>
+  </p:cSld>
+  <p:clrMapOvr>
+    <a:masterClrMapping/>
+  </p:clrMapOvr>
+</p:sld>
+</file>
+
 <file path=ppt/slides/slide3.xml><?xml version="1.0" encoding="utf-8"?>
 <p:sld xmlns:a="http://schemas.openxmlformats.org/drawingml/2006/main" xmlns:r="http://schemas.openxmlformats.org/officeDocument/2006/relationships" xmlns:p="http://schemas.openxmlformats.org/presentationml/2006/main">
   <p:cSld name="Slide 3">

</xml_diff>